<commit_message>
Update AgentAssigner workflow presentation
Co-authored-by: Copilot <223556219+Copilot@users.noreply.github.com>
</commit_message>
<xml_diff>
--- a/AgentAssigner/AgentAssigner_Workflow.pptx
+++ b/AgentAssigner/AgentAssigner_Workflow.pptx
@@ -5,12 +5,14 @@
     <p:sldMasterId id="2147483648" r:id="rId1"/>
   </p:sldMasterIdLst>
   <p:sldIdLst>
-    <p:sldId id="256" r:id="rId7"/>
-    <p:sldId id="257" r:id="rId8"/>
-    <p:sldId id="258" r:id="rId9"/>
-    <p:sldId id="259" r:id="rId10"/>
+    <p:sldId id="256" r:id="rId2"/>
+    <p:sldId id="257" r:id="rId3"/>
+    <p:sldId id="258" r:id="rId4"/>
+    <p:sldId id="259" r:id="rId5"/>
+    <p:sldId id="260" r:id="rId6"/>
+    <p:sldId id="261" r:id="rId7"/>
   </p:sldIdLst>
-  <p:sldSz cx="12191695" cy="6858000" type="screen4x3"/>
+  <p:sldSz cx="12192000" cy="6858000"/>
   <p:notesSz cx="6858000" cy="9144000"/>
   <p:defaultTextStyle>
     <a:defPPr>
@@ -107,6 +109,22 @@
       </a:defRPr>
     </a:lvl9pPr>
   </p:defaultTextStyle>
+  <p:extLst>
+    <p:ext uri="{EFAFB233-063F-42B5-8137-9DF3F51BA10A}">
+      <p15:sldGuideLst xmlns:p15="http://schemas.microsoft.com/office/powerpoint/2012/main">
+        <p15:guide id="1" orient="horz" pos="2160">
+          <p15:clr>
+            <a:srgbClr val="A4A3A4"/>
+          </p15:clr>
+        </p15:guide>
+        <p15:guide id="2" pos="2880">
+          <p15:clr>
+            <a:srgbClr val="A4A3A4"/>
+          </p15:clr>
+        </p15:guide>
+      </p15:sldGuideLst>
+    </p:ext>
+  </p:extLst>
 </p:presentation>
 </file>
 
@@ -148,10 +166,9 @@
           <a:lstStyle/>
           <a:p>
             <a:r>
-              <a:rPr lang="en-US" smtClean="0"/>
+              <a:rPr lang="en-US"/>
               <a:t>Click to edit Master title style</a:t>
             </a:r>
-            <a:endParaRPr lang="en-US"/>
           </a:p>
         </p:txBody>
       </p:sp>
@@ -267,10 +284,9 @@
           </a:lstStyle>
           <a:p>
             <a:r>
-              <a:rPr lang="en-US" smtClean="0"/>
+              <a:rPr lang="en-US"/>
               <a:t>Click to edit Master subtitle style</a:t>
             </a:r>
-            <a:endParaRPr lang="en-US"/>
           </a:p>
         </p:txBody>
       </p:sp>
@@ -291,7 +307,7 @@
           <a:p>
             <a:fld id="{5BCAD085-E8A6-8845-BD4E-CB4CCA059FC4}" type="datetimeFigureOut">
               <a:rPr lang="en-US" smtClean="0"/>
-              <a:t>1/27/13</a:t>
+              <a:t>10/31/2026</a:t>
             </a:fld>
             <a:endParaRPr lang="en-US"/>
           </a:p>
@@ -385,10 +401,9 @@
           <a:lstStyle/>
           <a:p>
             <a:r>
-              <a:rPr lang="en-US" smtClean="0"/>
+              <a:rPr lang="en-US"/>
               <a:t>Click to edit Master title style</a:t>
             </a:r>
-            <a:endParaRPr lang="en-US"/>
           </a:p>
         </p:txBody>
       </p:sp>
@@ -409,38 +424,37 @@
           <a:p>
             <a:pPr lvl="0"/>
             <a:r>
-              <a:rPr lang="en-US" smtClean="0"/>
+              <a:rPr lang="en-US"/>
               <a:t>Click to edit Master text styles</a:t>
             </a:r>
           </a:p>
           <a:p>
             <a:pPr lvl="1"/>
             <a:r>
-              <a:rPr lang="en-US" smtClean="0"/>
+              <a:rPr lang="en-US"/>
               <a:t>Second level</a:t>
             </a:r>
           </a:p>
           <a:p>
             <a:pPr lvl="2"/>
             <a:r>
-              <a:rPr lang="en-US" smtClean="0"/>
+              <a:rPr lang="en-US"/>
               <a:t>Third level</a:t>
             </a:r>
           </a:p>
           <a:p>
             <a:pPr lvl="3"/>
             <a:r>
-              <a:rPr lang="en-US" smtClean="0"/>
+              <a:rPr lang="en-US"/>
               <a:t>Fourth level</a:t>
             </a:r>
           </a:p>
           <a:p>
             <a:pPr lvl="4"/>
             <a:r>
-              <a:rPr lang="en-US" smtClean="0"/>
+              <a:rPr lang="en-US"/>
               <a:t>Fifth level</a:t>
             </a:r>
-            <a:endParaRPr lang="en-US"/>
           </a:p>
         </p:txBody>
       </p:sp>
@@ -461,7 +475,7 @@
           <a:p>
             <a:fld id="{5BCAD085-E8A6-8845-BD4E-CB4CCA059FC4}" type="datetimeFigureOut">
               <a:rPr lang="en-US" smtClean="0"/>
-              <a:t>1/27/13</a:t>
+              <a:t>10/31/2026</a:t>
             </a:fld>
             <a:endParaRPr lang="en-US"/>
           </a:p>
@@ -560,10 +574,9 @@
           <a:lstStyle/>
           <a:p>
             <a:r>
-              <a:rPr lang="en-US" smtClean="0"/>
+              <a:rPr lang="en-US"/>
               <a:t>Click to edit Master title style</a:t>
             </a:r>
-            <a:endParaRPr lang="en-US"/>
           </a:p>
         </p:txBody>
       </p:sp>
@@ -589,38 +602,37 @@
           <a:p>
             <a:pPr lvl="0"/>
             <a:r>
-              <a:rPr lang="en-US" smtClean="0"/>
+              <a:rPr lang="en-US"/>
               <a:t>Click to edit Master text styles</a:t>
             </a:r>
           </a:p>
           <a:p>
             <a:pPr lvl="1"/>
             <a:r>
-              <a:rPr lang="en-US" smtClean="0"/>
+              <a:rPr lang="en-US"/>
               <a:t>Second level</a:t>
             </a:r>
           </a:p>
           <a:p>
             <a:pPr lvl="2"/>
             <a:r>
-              <a:rPr lang="en-US" smtClean="0"/>
+              <a:rPr lang="en-US"/>
               <a:t>Third level</a:t>
             </a:r>
           </a:p>
           <a:p>
             <a:pPr lvl="3"/>
             <a:r>
-              <a:rPr lang="en-US" smtClean="0"/>
+              <a:rPr lang="en-US"/>
               <a:t>Fourth level</a:t>
             </a:r>
           </a:p>
           <a:p>
             <a:pPr lvl="4"/>
             <a:r>
-              <a:rPr lang="en-US" smtClean="0"/>
+              <a:rPr lang="en-US"/>
               <a:t>Fifth level</a:t>
             </a:r>
-            <a:endParaRPr lang="en-US"/>
           </a:p>
         </p:txBody>
       </p:sp>
@@ -641,7 +653,7 @@
           <a:p>
             <a:fld id="{5BCAD085-E8A6-8845-BD4E-CB4CCA059FC4}" type="datetimeFigureOut">
               <a:rPr lang="en-US" smtClean="0"/>
-              <a:t>1/27/13</a:t>
+              <a:t>10/31/2026</a:t>
             </a:fld>
             <a:endParaRPr lang="en-US"/>
           </a:p>
@@ -735,10 +747,9 @@
           <a:lstStyle/>
           <a:p>
             <a:r>
-              <a:rPr lang="en-US" smtClean="0"/>
+              <a:rPr lang="en-US"/>
               <a:t>Click to edit Master title style</a:t>
             </a:r>
-            <a:endParaRPr lang="en-US"/>
           </a:p>
         </p:txBody>
       </p:sp>
@@ -759,38 +770,37 @@
           <a:p>
             <a:pPr lvl="0"/>
             <a:r>
-              <a:rPr lang="en-US" smtClean="0"/>
+              <a:rPr lang="en-US"/>
               <a:t>Click to edit Master text styles</a:t>
             </a:r>
           </a:p>
           <a:p>
             <a:pPr lvl="1"/>
             <a:r>
-              <a:rPr lang="en-US" smtClean="0"/>
+              <a:rPr lang="en-US"/>
               <a:t>Second level</a:t>
             </a:r>
           </a:p>
           <a:p>
             <a:pPr lvl="2"/>
             <a:r>
-              <a:rPr lang="en-US" smtClean="0"/>
+              <a:rPr lang="en-US"/>
               <a:t>Third level</a:t>
             </a:r>
           </a:p>
           <a:p>
             <a:pPr lvl="3"/>
             <a:r>
-              <a:rPr lang="en-US" smtClean="0"/>
+              <a:rPr lang="en-US"/>
               <a:t>Fourth level</a:t>
             </a:r>
           </a:p>
           <a:p>
             <a:pPr lvl="4"/>
             <a:r>
-              <a:rPr lang="en-US" smtClean="0"/>
+              <a:rPr lang="en-US"/>
               <a:t>Fifth level</a:t>
             </a:r>
-            <a:endParaRPr lang="en-US"/>
           </a:p>
         </p:txBody>
       </p:sp>
@@ -811,7 +821,7 @@
           <a:p>
             <a:fld id="{5BCAD085-E8A6-8845-BD4E-CB4CCA059FC4}" type="datetimeFigureOut">
               <a:rPr lang="en-US" smtClean="0"/>
-              <a:t>1/27/13</a:t>
+              <a:t>10/31/2026</a:t>
             </a:fld>
             <a:endParaRPr lang="en-US"/>
           </a:p>
@@ -914,10 +924,9 @@
           </a:lstStyle>
           <a:p>
             <a:r>
-              <a:rPr lang="en-US" smtClean="0"/>
+              <a:rPr lang="en-US"/>
               <a:t>Click to edit Master title style</a:t>
             </a:r>
-            <a:endParaRPr lang="en-US"/>
           </a:p>
         </p:txBody>
       </p:sp>
@@ -1034,7 +1043,7 @@
           <a:p>
             <a:pPr lvl="0"/>
             <a:r>
-              <a:rPr lang="en-US" smtClean="0"/>
+              <a:rPr lang="en-US"/>
               <a:t>Click to edit Master text styles</a:t>
             </a:r>
           </a:p>
@@ -1057,7 +1066,7 @@
           <a:p>
             <a:fld id="{5BCAD085-E8A6-8845-BD4E-CB4CCA059FC4}" type="datetimeFigureOut">
               <a:rPr lang="en-US" smtClean="0"/>
-              <a:t>1/27/13</a:t>
+              <a:t>10/31/2026</a:t>
             </a:fld>
             <a:endParaRPr lang="en-US"/>
           </a:p>
@@ -1151,10 +1160,9 @@
           <a:lstStyle/>
           <a:p>
             <a:r>
-              <a:rPr lang="en-US" smtClean="0"/>
+              <a:rPr lang="en-US"/>
               <a:t>Click to edit Master title style</a:t>
             </a:r>
-            <a:endParaRPr lang="en-US"/>
           </a:p>
         </p:txBody>
       </p:sp>
@@ -1208,38 +1216,37 @@
           <a:p>
             <a:pPr lvl="0"/>
             <a:r>
-              <a:rPr lang="en-US" smtClean="0"/>
+              <a:rPr lang="en-US"/>
               <a:t>Click to edit Master text styles</a:t>
             </a:r>
           </a:p>
           <a:p>
             <a:pPr lvl="1"/>
             <a:r>
-              <a:rPr lang="en-US" smtClean="0"/>
+              <a:rPr lang="en-US"/>
               <a:t>Second level</a:t>
             </a:r>
           </a:p>
           <a:p>
             <a:pPr lvl="2"/>
             <a:r>
-              <a:rPr lang="en-US" smtClean="0"/>
+              <a:rPr lang="en-US"/>
               <a:t>Third level</a:t>
             </a:r>
           </a:p>
           <a:p>
             <a:pPr lvl="3"/>
             <a:r>
-              <a:rPr lang="en-US" smtClean="0"/>
+              <a:rPr lang="en-US"/>
               <a:t>Fourth level</a:t>
             </a:r>
           </a:p>
           <a:p>
             <a:pPr lvl="4"/>
             <a:r>
-              <a:rPr lang="en-US" smtClean="0"/>
+              <a:rPr lang="en-US"/>
               <a:t>Fifth level</a:t>
             </a:r>
-            <a:endParaRPr lang="en-US"/>
           </a:p>
         </p:txBody>
       </p:sp>
@@ -1293,38 +1300,37 @@
           <a:p>
             <a:pPr lvl="0"/>
             <a:r>
-              <a:rPr lang="en-US" smtClean="0"/>
+              <a:rPr lang="en-US"/>
               <a:t>Click to edit Master text styles</a:t>
             </a:r>
           </a:p>
           <a:p>
             <a:pPr lvl="1"/>
             <a:r>
-              <a:rPr lang="en-US" smtClean="0"/>
+              <a:rPr lang="en-US"/>
               <a:t>Second level</a:t>
             </a:r>
           </a:p>
           <a:p>
             <a:pPr lvl="2"/>
             <a:r>
-              <a:rPr lang="en-US" smtClean="0"/>
+              <a:rPr lang="en-US"/>
               <a:t>Third level</a:t>
             </a:r>
           </a:p>
           <a:p>
             <a:pPr lvl="3"/>
             <a:r>
-              <a:rPr lang="en-US" smtClean="0"/>
+              <a:rPr lang="en-US"/>
               <a:t>Fourth level</a:t>
             </a:r>
           </a:p>
           <a:p>
             <a:pPr lvl="4"/>
             <a:r>
-              <a:rPr lang="en-US" smtClean="0"/>
+              <a:rPr lang="en-US"/>
               <a:t>Fifth level</a:t>
             </a:r>
-            <a:endParaRPr lang="en-US"/>
           </a:p>
         </p:txBody>
       </p:sp>
@@ -1345,7 +1351,7 @@
           <a:p>
             <a:fld id="{5BCAD085-E8A6-8845-BD4E-CB4CCA059FC4}" type="datetimeFigureOut">
               <a:rPr lang="en-US" smtClean="0"/>
-              <a:t>1/27/13</a:t>
+              <a:t>10/31/2026</a:t>
             </a:fld>
             <a:endParaRPr lang="en-US"/>
           </a:p>
@@ -1443,10 +1449,9 @@
           </a:lstStyle>
           <a:p>
             <a:r>
-              <a:rPr lang="en-US" smtClean="0"/>
+              <a:rPr lang="en-US"/>
               <a:t>Click to edit Master title style</a:t>
             </a:r>
-            <a:endParaRPr lang="en-US"/>
           </a:p>
         </p:txBody>
       </p:sp>
@@ -1509,7 +1514,7 @@
           <a:p>
             <a:pPr lvl="0"/>
             <a:r>
-              <a:rPr lang="en-US" smtClean="0"/>
+              <a:rPr lang="en-US"/>
               <a:t>Click to edit Master text styles</a:t>
             </a:r>
           </a:p>
@@ -1565,38 +1570,37 @@
           <a:p>
             <a:pPr lvl="0"/>
             <a:r>
-              <a:rPr lang="en-US" smtClean="0"/>
+              <a:rPr lang="en-US"/>
               <a:t>Click to edit Master text styles</a:t>
             </a:r>
           </a:p>
           <a:p>
             <a:pPr lvl="1"/>
             <a:r>
-              <a:rPr lang="en-US" smtClean="0"/>
+              <a:rPr lang="en-US"/>
               <a:t>Second level</a:t>
             </a:r>
           </a:p>
           <a:p>
             <a:pPr lvl="2"/>
             <a:r>
-              <a:rPr lang="en-US" smtClean="0"/>
+              <a:rPr lang="en-US"/>
               <a:t>Third level</a:t>
             </a:r>
           </a:p>
           <a:p>
             <a:pPr lvl="3"/>
             <a:r>
-              <a:rPr lang="en-US" smtClean="0"/>
+              <a:rPr lang="en-US"/>
               <a:t>Fourth level</a:t>
             </a:r>
           </a:p>
           <a:p>
             <a:pPr lvl="4"/>
             <a:r>
-              <a:rPr lang="en-US" smtClean="0"/>
+              <a:rPr lang="en-US"/>
               <a:t>Fifth level</a:t>
             </a:r>
-            <a:endParaRPr lang="en-US"/>
           </a:p>
         </p:txBody>
       </p:sp>
@@ -1659,7 +1663,7 @@
           <a:p>
             <a:pPr lvl="0"/>
             <a:r>
-              <a:rPr lang="en-US" smtClean="0"/>
+              <a:rPr lang="en-US"/>
               <a:t>Click to edit Master text styles</a:t>
             </a:r>
           </a:p>
@@ -1715,38 +1719,37 @@
           <a:p>
             <a:pPr lvl="0"/>
             <a:r>
-              <a:rPr lang="en-US" smtClean="0"/>
+              <a:rPr lang="en-US"/>
               <a:t>Click to edit Master text styles</a:t>
             </a:r>
           </a:p>
           <a:p>
             <a:pPr lvl="1"/>
             <a:r>
-              <a:rPr lang="en-US" smtClean="0"/>
+              <a:rPr lang="en-US"/>
               <a:t>Second level</a:t>
             </a:r>
           </a:p>
           <a:p>
             <a:pPr lvl="2"/>
             <a:r>
-              <a:rPr lang="en-US" smtClean="0"/>
+              <a:rPr lang="en-US"/>
               <a:t>Third level</a:t>
             </a:r>
           </a:p>
           <a:p>
             <a:pPr lvl="3"/>
             <a:r>
-              <a:rPr lang="en-US" smtClean="0"/>
+              <a:rPr lang="en-US"/>
               <a:t>Fourth level</a:t>
             </a:r>
           </a:p>
           <a:p>
             <a:pPr lvl="4"/>
             <a:r>
-              <a:rPr lang="en-US" smtClean="0"/>
+              <a:rPr lang="en-US"/>
               <a:t>Fifth level</a:t>
             </a:r>
-            <a:endParaRPr lang="en-US"/>
           </a:p>
         </p:txBody>
       </p:sp>
@@ -1767,7 +1770,7 @@
           <a:p>
             <a:fld id="{5BCAD085-E8A6-8845-BD4E-CB4CCA059FC4}" type="datetimeFigureOut">
               <a:rPr lang="en-US" smtClean="0"/>
-              <a:t>1/27/13</a:t>
+              <a:t>10/31/2026</a:t>
             </a:fld>
             <a:endParaRPr lang="en-US"/>
           </a:p>
@@ -1861,10 +1864,9 @@
           <a:lstStyle/>
           <a:p>
             <a:r>
-              <a:rPr lang="en-US" smtClean="0"/>
+              <a:rPr lang="en-US"/>
               <a:t>Click to edit Master title style</a:t>
             </a:r>
-            <a:endParaRPr lang="en-US"/>
           </a:p>
         </p:txBody>
       </p:sp>
@@ -1885,7 +1887,7 @@
           <a:p>
             <a:fld id="{5BCAD085-E8A6-8845-BD4E-CB4CCA059FC4}" type="datetimeFigureOut">
               <a:rPr lang="en-US" smtClean="0"/>
-              <a:t>1/27/13</a:t>
+              <a:t>10/31/2026</a:t>
             </a:fld>
             <a:endParaRPr lang="en-US"/>
           </a:p>
@@ -1980,7 +1982,7 @@
           <a:p>
             <a:fld id="{5BCAD085-E8A6-8845-BD4E-CB4CCA059FC4}" type="datetimeFigureOut">
               <a:rPr lang="en-US" smtClean="0"/>
-              <a:t>1/27/13</a:t>
+              <a:t>10/31/2026</a:t>
             </a:fld>
             <a:endParaRPr lang="en-US"/>
           </a:p>
@@ -2083,10 +2085,9 @@
           </a:lstStyle>
           <a:p>
             <a:r>
-              <a:rPr lang="en-US" smtClean="0"/>
+              <a:rPr lang="en-US"/>
               <a:t>Click to edit Master title style</a:t>
             </a:r>
-            <a:endParaRPr lang="en-US"/>
           </a:p>
         </p:txBody>
       </p:sp>
@@ -2140,38 +2141,37 @@
           <a:p>
             <a:pPr lvl="0"/>
             <a:r>
-              <a:rPr lang="en-US" smtClean="0"/>
+              <a:rPr lang="en-US"/>
               <a:t>Click to edit Master text styles</a:t>
             </a:r>
           </a:p>
           <a:p>
             <a:pPr lvl="1"/>
             <a:r>
-              <a:rPr lang="en-US" smtClean="0"/>
+              <a:rPr lang="en-US"/>
               <a:t>Second level</a:t>
             </a:r>
           </a:p>
           <a:p>
             <a:pPr lvl="2"/>
             <a:r>
-              <a:rPr lang="en-US" smtClean="0"/>
+              <a:rPr lang="en-US"/>
               <a:t>Third level</a:t>
             </a:r>
           </a:p>
           <a:p>
             <a:pPr lvl="3"/>
             <a:r>
-              <a:rPr lang="en-US" smtClean="0"/>
+              <a:rPr lang="en-US"/>
               <a:t>Fourth level</a:t>
             </a:r>
           </a:p>
           <a:p>
             <a:pPr lvl="4"/>
             <a:r>
-              <a:rPr lang="en-US" smtClean="0"/>
+              <a:rPr lang="en-US"/>
               <a:t>Fifth level</a:t>
             </a:r>
-            <a:endParaRPr lang="en-US"/>
           </a:p>
         </p:txBody>
       </p:sp>
@@ -2234,7 +2234,7 @@
           <a:p>
             <a:pPr lvl="0"/>
             <a:r>
-              <a:rPr lang="en-US" smtClean="0"/>
+              <a:rPr lang="en-US"/>
               <a:t>Click to edit Master text styles</a:t>
             </a:r>
           </a:p>
@@ -2257,7 +2257,7 @@
           <a:p>
             <a:fld id="{5BCAD085-E8A6-8845-BD4E-CB4CCA059FC4}" type="datetimeFigureOut">
               <a:rPr lang="en-US" smtClean="0"/>
-              <a:t>1/27/13</a:t>
+              <a:t>10/31/2026</a:t>
             </a:fld>
             <a:endParaRPr lang="en-US"/>
           </a:p>
@@ -2360,10 +2360,9 @@
           </a:lstStyle>
           <a:p>
             <a:r>
-              <a:rPr lang="en-US" smtClean="0"/>
+              <a:rPr lang="en-US"/>
               <a:t>Click to edit Master title style</a:t>
             </a:r>
-            <a:endParaRPr lang="en-US"/>
           </a:p>
         </p:txBody>
       </p:sp>
@@ -2487,7 +2486,7 @@
           <a:p>
             <a:pPr lvl="0"/>
             <a:r>
-              <a:rPr lang="en-US" smtClean="0"/>
+              <a:rPr lang="en-US"/>
               <a:t>Click to edit Master text styles</a:t>
             </a:r>
           </a:p>
@@ -2510,7 +2509,7 @@
           <a:p>
             <a:fld id="{5BCAD085-E8A6-8845-BD4E-CB4CCA059FC4}" type="datetimeFigureOut">
               <a:rPr lang="en-US" smtClean="0"/>
-              <a:t>1/27/13</a:t>
+              <a:t>10/31/2026</a:t>
             </a:fld>
             <a:endParaRPr lang="en-US"/>
           </a:p>
@@ -2619,10 +2618,9 @@
           <a:lstStyle/>
           <a:p>
             <a:r>
-              <a:rPr lang="en-US" smtClean="0"/>
+              <a:rPr lang="en-US"/>
               <a:t>Click to edit Master title style</a:t>
             </a:r>
-            <a:endParaRPr lang="en-US"/>
           </a:p>
         </p:txBody>
       </p:sp>
@@ -2653,38 +2651,37 @@
           <a:p>
             <a:pPr lvl="0"/>
             <a:r>
-              <a:rPr lang="en-US" smtClean="0"/>
+              <a:rPr lang="en-US"/>
               <a:t>Click to edit Master text styles</a:t>
             </a:r>
           </a:p>
           <a:p>
             <a:pPr lvl="1"/>
             <a:r>
-              <a:rPr lang="en-US" smtClean="0"/>
+              <a:rPr lang="en-US"/>
               <a:t>Second level</a:t>
             </a:r>
           </a:p>
           <a:p>
             <a:pPr lvl="2"/>
             <a:r>
-              <a:rPr lang="en-US" smtClean="0"/>
+              <a:rPr lang="en-US"/>
               <a:t>Third level</a:t>
             </a:r>
           </a:p>
           <a:p>
             <a:pPr lvl="3"/>
             <a:r>
-              <a:rPr lang="en-US" smtClean="0"/>
+              <a:rPr lang="en-US"/>
               <a:t>Fourth level</a:t>
             </a:r>
           </a:p>
           <a:p>
             <a:pPr lvl="4"/>
             <a:r>
-              <a:rPr lang="en-US" smtClean="0"/>
+              <a:rPr lang="en-US"/>
               <a:t>Fifth level</a:t>
             </a:r>
-            <a:endParaRPr lang="en-US"/>
           </a:p>
         </p:txBody>
       </p:sp>
@@ -2723,7 +2720,7 @@
           <a:p>
             <a:fld id="{5BCAD085-E8A6-8845-BD4E-CB4CCA059FC4}" type="datetimeFigureOut">
               <a:rPr lang="en-US" smtClean="0"/>
-              <a:t>1/27/13</a:t>
+              <a:t>10/31/2026</a:t>
             </a:fld>
             <a:endParaRPr lang="en-US"/>
           </a:p>
@@ -3082,7 +3079,7 @@
 </file>
 
 <file path=ppt/slides/slide1.xml><?xml version="1.0" encoding="utf-8"?>
-<p:sld xmlns:a="http://schemas.openxmlformats.org/drawingml/2006/main" xmlns:p="http://schemas.openxmlformats.org/presentationml/2006/main" xmlns:r="http://schemas.openxmlformats.org/officeDocument/2006/relationships">
+<p:sld xmlns:a="http://schemas.openxmlformats.org/drawingml/2006/main" xmlns:r="http://schemas.openxmlformats.org/officeDocument/2006/relationships" xmlns:p="http://schemas.openxmlformats.org/presentationml/2006/main">
   <p:cSld>
     <p:spTree>
       <p:nvGrpSpPr>
@@ -3090,7 +3087,14 @@
         <p:cNvGrpSpPr/>
         <p:nvPr/>
       </p:nvGrpSpPr>
-      <p:grpSpPr/>
+      <p:grpSpPr>
+        <a:xfrm>
+          <a:off x="0" y="0"/>
+          <a:ext cx="0" cy="0"/>
+          <a:chOff x="0" y="0"/>
+          <a:chExt cx="0" cy="0"/>
+        </a:xfrm>
+      </p:grpSpPr>
       <p:sp>
         <p:nvSpPr>
           <p:cNvPr id="2" name="Rectangle 1"/>
@@ -3132,6 +3136,7 @@
           <a:lstStyle/>
           <a:p>
             <a:pPr algn="ctr"/>
+            <a:endParaRPr/>
           </a:p>
         </p:txBody>
       </p:sp>
@@ -3176,6 +3181,7 @@
           <a:lstStyle/>
           <a:p>
             <a:pPr algn="ctr"/>
+            <a:endParaRPr/>
           </a:p>
         </p:txBody>
       </p:sp>
@@ -3196,7 +3202,7 @@
           <a:noFill/>
         </p:spPr>
         <p:txBody>
-          <a:bodyPr wrap="square" anchor="ctr" lIns="109728" rIns="109728">
+          <a:bodyPr wrap="square" lIns="109728" rIns="109728" anchor="ctr">
             <a:spAutoFit/>
           </a:bodyPr>
           <a:lstStyle/>
@@ -3235,7 +3241,7 @@
           <a:noFill/>
         </p:spPr>
         <p:txBody>
-          <a:bodyPr wrap="square" anchor="ctr" lIns="109728" rIns="109728">
+          <a:bodyPr wrap="square" lIns="109728" rIns="109728" anchor="ctr">
             <a:spAutoFit/>
           </a:bodyPr>
           <a:lstStyle/>
@@ -3294,7 +3300,7 @@
           </a:fontRef>
         </p:style>
         <p:txBody>
-          <a:bodyPr rtlCol="0" anchor="ctr" wrap="square" lIns="0" rIns="0"/>
+          <a:bodyPr wrap="square" lIns="0" rIns="0" rtlCol="0" anchor="ctr"/>
           <a:lstStyle/>
           <a:p>
             <a:pPr algn="ctr">
@@ -3355,6 +3361,7 @@
           <a:lstStyle/>
           <a:p>
             <a:pPr algn="ctr"/>
+            <a:endParaRPr/>
           </a:p>
         </p:txBody>
       </p:sp>
@@ -3375,7 +3382,7 @@
           <a:noFill/>
         </p:spPr>
         <p:txBody>
-          <a:bodyPr wrap="square" anchor="ctr" lIns="109728" rIns="109728">
+          <a:bodyPr wrap="square" lIns="109728" rIns="109728" anchor="ctr">
             <a:spAutoFit/>
           </a:bodyPr>
           <a:lstStyle/>
@@ -3436,7 +3443,7 @@
           </a:fontRef>
         </p:style>
         <p:txBody>
-          <a:bodyPr rtlCol="0" anchor="t" wrap="square" lIns="228600" rIns="228600"/>
+          <a:bodyPr wrap="square" lIns="228600" rIns="228600" rtlCol="0" anchor="t"/>
           <a:lstStyle/>
           <a:p>
             <a:pPr algn="l">
@@ -3445,7 +3452,7 @@
               </a:spcAft>
             </a:pPr>
             <a:r>
-              <a:rPr sz="2000" b="1">
+              <a:rPr sz="2000" b="1" dirty="0">
                 <a:solidFill>
                   <a:srgbClr val="0F233F"/>
                 </a:solidFill>
@@ -3461,13 +3468,31 @@
               </a:spcAft>
             </a:pPr>
             <a:r>
-              <a:rPr sz="1400" b="0">
+              <a:rPr sz="1400" b="0" dirty="0">
                 <a:solidFill>
                   <a:srgbClr val="222B38"/>
                 </a:solidFill>
                 <a:latin typeface="Calibri"/>
               </a:rPr>
-              <a:t>A FastAPI microservice. When a user clicks the tick on a bug, the bug is assigned to an LLM debugging agent.</a:t>
+              <a:t>A </a:t>
+            </a:r>
+            <a:r>
+              <a:rPr sz="1400" b="0" dirty="0" err="1">
+                <a:solidFill>
+                  <a:srgbClr val="222B38"/>
+                </a:solidFill>
+                <a:latin typeface="Calibri"/>
+              </a:rPr>
+              <a:t>FastAPI</a:t>
+            </a:r>
+            <a:r>
+              <a:rPr sz="1400" b="0" dirty="0">
+                <a:solidFill>
+                  <a:srgbClr val="222B38"/>
+                </a:solidFill>
+                <a:latin typeface="Calibri"/>
+              </a:rPr>
+              <a:t> microservice. When a user clicks the tick on a bug, the bug is assigned to an LLM debugging agent.</a:t>
             </a:r>
           </a:p>
           <a:p>
@@ -3477,7 +3502,7 @@
               </a:spcAft>
             </a:pPr>
             <a:r>
-              <a:rPr sz="1400" b="0">
+              <a:rPr sz="1400" b="0" dirty="0">
                 <a:solidFill>
                   <a:srgbClr val="222B38"/>
                 </a:solidFill>
@@ -3493,7 +3518,7 @@
               </a:spcAft>
             </a:pPr>
             <a:r>
-              <a:rPr sz="1400" b="0">
+              <a:rPr sz="1400" b="0" dirty="0">
                 <a:solidFill>
                   <a:srgbClr val="222B38"/>
                 </a:solidFill>
@@ -3509,7 +3534,7 @@
               </a:spcAft>
             </a:pPr>
             <a:r>
-              <a:rPr sz="1400" b="1">
+              <a:rPr sz="1400" b="1" dirty="0">
                 <a:solidFill>
                   <a:srgbClr val="0E9F9A"/>
                 </a:solidFill>
@@ -3537,7 +3562,7 @@
           <a:noFill/>
         </p:spPr>
         <p:txBody>
-          <a:bodyPr wrap="square" anchor="ctr" lIns="109728" rIns="109728">
+          <a:bodyPr wrap="square" lIns="109728" rIns="109728" anchor="ctr">
             <a:spAutoFit/>
           </a:bodyPr>
           <a:lstStyle/>
@@ -3598,7 +3623,7 @@
           </a:fontRef>
         </p:style>
         <p:txBody>
-          <a:bodyPr rtlCol="0" anchor="ctr" wrap="square" lIns="109728" rIns="109728"/>
+          <a:bodyPr wrap="square" lIns="109728" rIns="109728" rtlCol="0" anchor="ctr"/>
           <a:lstStyle/>
           <a:p>
             <a:pPr algn="ctr">
@@ -3675,6 +3700,7 @@
           <a:lstStyle/>
           <a:p>
             <a:pPr algn="ctr"/>
+            <a:endParaRPr/>
           </a:p>
         </p:txBody>
       </p:sp>
@@ -3717,7 +3743,7 @@
           </a:fontRef>
         </p:style>
         <p:txBody>
-          <a:bodyPr rtlCol="0" anchor="ctr" wrap="square" lIns="109728" rIns="109728"/>
+          <a:bodyPr wrap="square" lIns="109728" rIns="109728" rtlCol="0" anchor="ctr"/>
           <a:lstStyle/>
           <a:p>
             <a:pPr algn="ctr">
@@ -3794,6 +3820,7 @@
           <a:lstStyle/>
           <a:p>
             <a:pPr algn="ctr"/>
+            <a:endParaRPr/>
           </a:p>
         </p:txBody>
       </p:sp>
@@ -3836,7 +3863,7 @@
           </a:fontRef>
         </p:style>
         <p:txBody>
-          <a:bodyPr rtlCol="0" anchor="ctr" wrap="square" lIns="109728" rIns="109728"/>
+          <a:bodyPr wrap="square" lIns="109728" rIns="109728" rtlCol="0" anchor="ctr"/>
           <a:lstStyle/>
           <a:p>
             <a:pPr algn="ctr">
@@ -3913,6 +3940,7 @@
           <a:lstStyle/>
           <a:p>
             <a:pPr algn="ctr"/>
+            <a:endParaRPr/>
           </a:p>
         </p:txBody>
       </p:sp>
@@ -3957,7 +3985,7 @@
           </a:fontRef>
         </p:style>
         <p:txBody>
-          <a:bodyPr rtlCol="0" anchor="ctr" wrap="square" lIns="109728" rIns="109728"/>
+          <a:bodyPr wrap="square" lIns="109728" rIns="109728" rtlCol="0" anchor="ctr"/>
           <a:lstStyle/>
           <a:p>
             <a:pPr algn="ctr">
@@ -4034,6 +4062,7 @@
           <a:lstStyle/>
           <a:p>
             <a:pPr algn="ctr"/>
+            <a:endParaRPr/>
           </a:p>
         </p:txBody>
       </p:sp>
@@ -4078,7 +4107,7 @@
           </a:fontRef>
         </p:style>
         <p:txBody>
-          <a:bodyPr rtlCol="0" anchor="ctr" wrap="square" lIns="109728" rIns="109728"/>
+          <a:bodyPr wrap="square" lIns="109728" rIns="109728" rtlCol="0" anchor="ctr"/>
           <a:lstStyle/>
           <a:p>
             <a:pPr algn="ctr">
@@ -4116,14 +4145,14 @@
       </p:sp>
       <p:sp>
         <p:nvSpPr>
-          <p:cNvPr id="20" name="TextBox 19"/>
+          <p:cNvPr id="28" name="TextBox 27"/>
           <p:cNvSpPr txBox="1"/>
           <p:nvPr/>
         </p:nvSpPr>
         <p:spPr>
           <a:xfrm>
-            <a:off x="548640" y="4892040"/>
-            <a:ext cx="4572000" cy="365760"/>
+            <a:off x="548640" y="5943600"/>
+            <a:ext cx="10972800" cy="457200"/>
           </a:xfrm>
           <a:prstGeom prst="rect">
             <a:avLst/>
@@ -4131,473 +4160,7 @@
           <a:noFill/>
         </p:spPr>
         <p:txBody>
-          <a:bodyPr wrap="square" anchor="ctr" lIns="109728" rIns="109728">
-            <a:spAutoFit/>
-          </a:bodyPr>
-          <a:lstStyle/>
-          <a:p>
-            <a:pPr algn="l">
-              <a:spcAft>
-                <a:spcPts val="200"/>
-              </a:spcAft>
-            </a:pPr>
-            <a:r>
-              <a:rPr sz="1600" b="1">
-                <a:solidFill>
-                  <a:srgbClr val="0F233F"/>
-                </a:solidFill>
-                <a:latin typeface="Calibri"/>
-              </a:rPr>
-              <a:t>Built with</a:t>
-            </a:r>
-          </a:p>
-        </p:txBody>
-      </p:sp>
-      <p:sp>
-        <p:nvSpPr>
-          <p:cNvPr id="21" name="Rounded Rectangle 20"/>
-          <p:cNvSpPr/>
-          <p:nvPr/>
-        </p:nvSpPr>
-        <p:spPr>
-          <a:xfrm>
-            <a:off x="548640" y="5349240"/>
-            <a:ext cx="905256" cy="384048"/>
-          </a:xfrm>
-          <a:prstGeom prst="roundRect">
-            <a:avLst>
-              <a:gd name="adj" fmla="val 50000"/>
-            </a:avLst>
-          </a:prstGeom>
-          <a:solidFill>
-            <a:srgbClr val="FFFFFF"/>
-          </a:solidFill>
-          <a:ln w="15875">
-            <a:solidFill>
-              <a:srgbClr val="0E9F9A"/>
-            </a:solidFill>
-          </a:ln>
-          <a:effectLst/>
-        </p:spPr>
-        <p:style>
-          <a:lnRef idx="1">
-            <a:schemeClr val="accent1"/>
-          </a:lnRef>
-          <a:fillRef idx="3">
-            <a:schemeClr val="accent1"/>
-          </a:fillRef>
-          <a:effectRef idx="2">
-            <a:schemeClr val="accent1"/>
-          </a:effectRef>
-          <a:fontRef idx="minor">
-            <a:schemeClr val="lt1"/>
-          </a:fontRef>
-        </p:style>
-        <p:txBody>
-          <a:bodyPr rtlCol="0" anchor="ctr" wrap="square" lIns="45720" rIns="45720"/>
-          <a:lstStyle/>
-          <a:p>
-            <a:pPr algn="ctr">
-              <a:spcAft>
-                <a:spcPts val="200"/>
-              </a:spcAft>
-            </a:pPr>
-            <a:r>
-              <a:rPr sz="1200" b="1">
-                <a:solidFill>
-                  <a:srgbClr val="0E9F9A"/>
-                </a:solidFill>
-                <a:latin typeface="Calibri"/>
-              </a:rPr>
-              <a:t>Python</a:t>
-            </a:r>
-          </a:p>
-        </p:txBody>
-      </p:sp>
-      <p:sp>
-        <p:nvSpPr>
-          <p:cNvPr id="22" name="Rounded Rectangle 21"/>
-          <p:cNvSpPr/>
-          <p:nvPr/>
-        </p:nvSpPr>
-        <p:spPr>
-          <a:xfrm>
-            <a:off x="1591055" y="5349240"/>
-            <a:ext cx="1010412" cy="384048"/>
-          </a:xfrm>
-          <a:prstGeom prst="roundRect">
-            <a:avLst>
-              <a:gd name="adj" fmla="val 50000"/>
-            </a:avLst>
-          </a:prstGeom>
-          <a:solidFill>
-            <a:srgbClr val="FFFFFF"/>
-          </a:solidFill>
-          <a:ln w="15875">
-            <a:solidFill>
-              <a:srgbClr val="0E9F9A"/>
-            </a:solidFill>
-          </a:ln>
-          <a:effectLst/>
-        </p:spPr>
-        <p:style>
-          <a:lnRef idx="1">
-            <a:schemeClr val="accent1"/>
-          </a:lnRef>
-          <a:fillRef idx="3">
-            <a:schemeClr val="accent1"/>
-          </a:fillRef>
-          <a:effectRef idx="2">
-            <a:schemeClr val="accent1"/>
-          </a:effectRef>
-          <a:fontRef idx="minor">
-            <a:schemeClr val="lt1"/>
-          </a:fontRef>
-        </p:style>
-        <p:txBody>
-          <a:bodyPr rtlCol="0" anchor="ctr" wrap="square" lIns="45720" rIns="45720"/>
-          <a:lstStyle/>
-          <a:p>
-            <a:pPr algn="ctr">
-              <a:spcAft>
-                <a:spcPts val="200"/>
-              </a:spcAft>
-            </a:pPr>
-            <a:r>
-              <a:rPr sz="1200" b="1">
-                <a:solidFill>
-                  <a:srgbClr val="0E9F9A"/>
-                </a:solidFill>
-                <a:latin typeface="Calibri"/>
-              </a:rPr>
-              <a:t>FastAPI</a:t>
-            </a:r>
-          </a:p>
-        </p:txBody>
-      </p:sp>
-      <p:sp>
-        <p:nvSpPr>
-          <p:cNvPr id="23" name="Rounded Rectangle 22"/>
-          <p:cNvSpPr/>
-          <p:nvPr/>
-        </p:nvSpPr>
-        <p:spPr>
-          <a:xfrm>
-            <a:off x="2738627" y="5349240"/>
-            <a:ext cx="1115568" cy="384048"/>
-          </a:xfrm>
-          <a:prstGeom prst="roundRect">
-            <a:avLst>
-              <a:gd name="adj" fmla="val 50000"/>
-            </a:avLst>
-          </a:prstGeom>
-          <a:solidFill>
-            <a:srgbClr val="FFFFFF"/>
-          </a:solidFill>
-          <a:ln w="15875">
-            <a:solidFill>
-              <a:srgbClr val="0E9F9A"/>
-            </a:solidFill>
-          </a:ln>
-          <a:effectLst/>
-        </p:spPr>
-        <p:style>
-          <a:lnRef idx="1">
-            <a:schemeClr val="accent1"/>
-          </a:lnRef>
-          <a:fillRef idx="3">
-            <a:schemeClr val="accent1"/>
-          </a:fillRef>
-          <a:effectRef idx="2">
-            <a:schemeClr val="accent1"/>
-          </a:effectRef>
-          <a:fontRef idx="minor">
-            <a:schemeClr val="lt1"/>
-          </a:fontRef>
-        </p:style>
-        <p:txBody>
-          <a:bodyPr rtlCol="0" anchor="ctr" wrap="square" lIns="45720" rIns="45720"/>
-          <a:lstStyle/>
-          <a:p>
-            <a:pPr algn="ctr">
-              <a:spcAft>
-                <a:spcPts val="200"/>
-              </a:spcAft>
-            </a:pPr>
-            <a:r>
-              <a:rPr sz="1200" b="1">
-                <a:solidFill>
-                  <a:srgbClr val="0E9F9A"/>
-                </a:solidFill>
-                <a:latin typeface="Calibri"/>
-              </a:rPr>
-              <a:t>Pydantic</a:t>
-            </a:r>
-          </a:p>
-        </p:txBody>
-      </p:sp>
-      <p:sp>
-        <p:nvSpPr>
-          <p:cNvPr id="24" name="Rounded Rectangle 23"/>
-          <p:cNvSpPr/>
-          <p:nvPr/>
-        </p:nvSpPr>
-        <p:spPr>
-          <a:xfrm>
-            <a:off x="3991355" y="5349240"/>
-            <a:ext cx="800100" cy="384048"/>
-          </a:xfrm>
-          <a:prstGeom prst="roundRect">
-            <a:avLst>
-              <a:gd name="adj" fmla="val 50000"/>
-            </a:avLst>
-          </a:prstGeom>
-          <a:solidFill>
-            <a:srgbClr val="FFFFFF"/>
-          </a:solidFill>
-          <a:ln w="15875">
-            <a:solidFill>
-              <a:srgbClr val="0E9F9A"/>
-            </a:solidFill>
-          </a:ln>
-          <a:effectLst/>
-        </p:spPr>
-        <p:style>
-          <a:lnRef idx="1">
-            <a:schemeClr val="accent1"/>
-          </a:lnRef>
-          <a:fillRef idx="3">
-            <a:schemeClr val="accent1"/>
-          </a:fillRef>
-          <a:effectRef idx="2">
-            <a:schemeClr val="accent1"/>
-          </a:effectRef>
-          <a:fontRef idx="minor">
-            <a:schemeClr val="lt1"/>
-          </a:fontRef>
-        </p:style>
-        <p:txBody>
-          <a:bodyPr rtlCol="0" anchor="ctr" wrap="square" lIns="45720" rIns="45720"/>
-          <a:lstStyle/>
-          <a:p>
-            <a:pPr algn="ctr">
-              <a:spcAft>
-                <a:spcPts val="200"/>
-              </a:spcAft>
-            </a:pPr>
-            <a:r>
-              <a:rPr sz="1200" b="1">
-                <a:solidFill>
-                  <a:srgbClr val="0E9F9A"/>
-                </a:solidFill>
-                <a:latin typeface="Calibri"/>
-              </a:rPr>
-              <a:t>httpx</a:t>
-            </a:r>
-          </a:p>
-        </p:txBody>
-      </p:sp>
-      <p:sp>
-        <p:nvSpPr>
-          <p:cNvPr id="25" name="Rounded Rectangle 24"/>
-          <p:cNvSpPr/>
-          <p:nvPr/>
-        </p:nvSpPr>
-        <p:spPr>
-          <a:xfrm>
-            <a:off x="4928615" y="5349240"/>
-            <a:ext cx="1851660" cy="384048"/>
-          </a:xfrm>
-          <a:prstGeom prst="roundRect">
-            <a:avLst>
-              <a:gd name="adj" fmla="val 50000"/>
-            </a:avLst>
-          </a:prstGeom>
-          <a:solidFill>
-            <a:srgbClr val="FFFFFF"/>
-          </a:solidFill>
-          <a:ln w="15875">
-            <a:solidFill>
-              <a:srgbClr val="0E9F9A"/>
-            </a:solidFill>
-          </a:ln>
-          <a:effectLst/>
-        </p:spPr>
-        <p:style>
-          <a:lnRef idx="1">
-            <a:schemeClr val="accent1"/>
-          </a:lnRef>
-          <a:fillRef idx="3">
-            <a:schemeClr val="accent1"/>
-          </a:fillRef>
-          <a:effectRef idx="2">
-            <a:schemeClr val="accent1"/>
-          </a:effectRef>
-          <a:fontRef idx="minor">
-            <a:schemeClr val="lt1"/>
-          </a:fontRef>
-        </p:style>
-        <p:txBody>
-          <a:bodyPr rtlCol="0" anchor="ctr" wrap="square" lIns="45720" rIns="45720"/>
-          <a:lstStyle/>
-          <a:p>
-            <a:pPr algn="ctr">
-              <a:spcAft>
-                <a:spcPts val="200"/>
-              </a:spcAft>
-            </a:pPr>
-            <a:r>
-              <a:rPr sz="1200" b="1">
-                <a:solidFill>
-                  <a:srgbClr val="0E9F9A"/>
-                </a:solidFill>
-                <a:latin typeface="Calibri"/>
-              </a:rPr>
-              <a:t>Gemini / Claude</a:t>
-            </a:r>
-          </a:p>
-        </p:txBody>
-      </p:sp>
-      <p:sp>
-        <p:nvSpPr>
-          <p:cNvPr id="26" name="Rounded Rectangle 25"/>
-          <p:cNvSpPr/>
-          <p:nvPr/>
-        </p:nvSpPr>
-        <p:spPr>
-          <a:xfrm>
-            <a:off x="6917435" y="5349240"/>
-            <a:ext cx="905256" cy="384048"/>
-          </a:xfrm>
-          <a:prstGeom prst="roundRect">
-            <a:avLst>
-              <a:gd name="adj" fmla="val 50000"/>
-            </a:avLst>
-          </a:prstGeom>
-          <a:solidFill>
-            <a:srgbClr val="FFFFFF"/>
-          </a:solidFill>
-          <a:ln w="15875">
-            <a:solidFill>
-              <a:srgbClr val="0E9F9A"/>
-            </a:solidFill>
-          </a:ln>
-          <a:effectLst/>
-        </p:spPr>
-        <p:style>
-          <a:lnRef idx="1">
-            <a:schemeClr val="accent1"/>
-          </a:lnRef>
-          <a:fillRef idx="3">
-            <a:schemeClr val="accent1"/>
-          </a:fillRef>
-          <a:effectRef idx="2">
-            <a:schemeClr val="accent1"/>
-          </a:effectRef>
-          <a:fontRef idx="minor">
-            <a:schemeClr val="lt1"/>
-          </a:fontRef>
-        </p:style>
-        <p:txBody>
-          <a:bodyPr rtlCol="0" anchor="ctr" wrap="square" lIns="45720" rIns="45720"/>
-          <a:lstStyle/>
-          <a:p>
-            <a:pPr algn="ctr">
-              <a:spcAft>
-                <a:spcPts val="200"/>
-              </a:spcAft>
-            </a:pPr>
-            <a:r>
-              <a:rPr sz="1200" b="1">
-                <a:solidFill>
-                  <a:srgbClr val="0E9F9A"/>
-                </a:solidFill>
-                <a:latin typeface="Calibri"/>
-              </a:rPr>
-              <a:t>Docker</a:t>
-            </a:r>
-          </a:p>
-        </p:txBody>
-      </p:sp>
-      <p:sp>
-        <p:nvSpPr>
-          <p:cNvPr id="27" name="Rounded Rectangle 26"/>
-          <p:cNvSpPr/>
-          <p:nvPr/>
-        </p:nvSpPr>
-        <p:spPr>
-          <a:xfrm>
-            <a:off x="7959851" y="5349240"/>
-            <a:ext cx="905256" cy="384048"/>
-          </a:xfrm>
-          <a:prstGeom prst="roundRect">
-            <a:avLst>
-              <a:gd name="adj" fmla="val 50000"/>
-            </a:avLst>
-          </a:prstGeom>
-          <a:solidFill>
-            <a:srgbClr val="FFFFFF"/>
-          </a:solidFill>
-          <a:ln w="15875">
-            <a:solidFill>
-              <a:srgbClr val="0E9F9A"/>
-            </a:solidFill>
-          </a:ln>
-          <a:effectLst/>
-        </p:spPr>
-        <p:style>
-          <a:lnRef idx="1">
-            <a:schemeClr val="accent1"/>
-          </a:lnRef>
-          <a:fillRef idx="3">
-            <a:schemeClr val="accent1"/>
-          </a:fillRef>
-          <a:effectRef idx="2">
-            <a:schemeClr val="accent1"/>
-          </a:effectRef>
-          <a:fontRef idx="minor">
-            <a:schemeClr val="lt1"/>
-          </a:fontRef>
-        </p:style>
-        <p:txBody>
-          <a:bodyPr rtlCol="0" anchor="ctr" wrap="square" lIns="45720" rIns="45720"/>
-          <a:lstStyle/>
-          <a:p>
-            <a:pPr algn="ctr">
-              <a:spcAft>
-                <a:spcPts val="200"/>
-              </a:spcAft>
-            </a:pPr>
-            <a:r>
-              <a:rPr sz="1200" b="1">
-                <a:solidFill>
-                  <a:srgbClr val="0E9F9A"/>
-                </a:solidFill>
-                <a:latin typeface="Calibri"/>
-              </a:rPr>
-              <a:t>pytest</a:t>
-            </a:r>
-          </a:p>
-        </p:txBody>
-      </p:sp>
-      <p:sp>
-        <p:nvSpPr>
-          <p:cNvPr id="28" name="TextBox 27"/>
-          <p:cNvSpPr txBox="1"/>
-          <p:nvPr/>
-        </p:nvSpPr>
-        <p:spPr>
-          <a:xfrm>
-            <a:off x="548640" y="5943600"/>
-            <a:ext cx="10972800" cy="457200"/>
-          </a:xfrm>
-          <a:prstGeom prst="rect">
-            <a:avLst/>
-          </a:prstGeom>
-          <a:noFill/>
-        </p:spPr>
-        <p:txBody>
-          <a:bodyPr wrap="square" anchor="ctr" lIns="109728" rIns="109728">
+          <a:bodyPr wrap="square" lIns="109728" rIns="109728" anchor="ctr">
             <a:spAutoFit/>
           </a:bodyPr>
           <a:lstStyle/>
@@ -4628,7 +4191,7 @@
 </file>
 
 <file path=ppt/slides/slide2.xml><?xml version="1.0" encoding="utf-8"?>
-<p:sld xmlns:a="http://schemas.openxmlformats.org/drawingml/2006/main" xmlns:p="http://schemas.openxmlformats.org/presentationml/2006/main" xmlns:r="http://schemas.openxmlformats.org/officeDocument/2006/relationships">
+<p:sld xmlns:a="http://schemas.openxmlformats.org/drawingml/2006/main" xmlns:r="http://schemas.openxmlformats.org/officeDocument/2006/relationships" xmlns:p="http://schemas.openxmlformats.org/presentationml/2006/main">
   <p:cSld>
     <p:spTree>
       <p:nvGrpSpPr>
@@ -4636,7 +4199,14 @@
         <p:cNvGrpSpPr/>
         <p:nvPr/>
       </p:nvGrpSpPr>
-      <p:grpSpPr/>
+      <p:grpSpPr>
+        <a:xfrm>
+          <a:off x="0" y="0"/>
+          <a:ext cx="0" cy="0"/>
+          <a:chOff x="0" y="0"/>
+          <a:chExt cx="0" cy="0"/>
+        </a:xfrm>
+      </p:grpSpPr>
       <p:sp>
         <p:nvSpPr>
           <p:cNvPr id="2" name="Rectangle 1"/>
@@ -4678,6 +4248,7 @@
           <a:lstStyle/>
           <a:p>
             <a:pPr algn="ctr"/>
+            <a:endParaRPr/>
           </a:p>
         </p:txBody>
       </p:sp>
@@ -4722,6 +4293,7 @@
           <a:lstStyle/>
           <a:p>
             <a:pPr algn="ctr"/>
+            <a:endParaRPr/>
           </a:p>
         </p:txBody>
       </p:sp>
@@ -4742,7 +4314,7 @@
           <a:noFill/>
         </p:spPr>
         <p:txBody>
-          <a:bodyPr wrap="square" anchor="ctr" lIns="109728" rIns="109728">
+          <a:bodyPr wrap="square" lIns="109728" rIns="109728" anchor="ctr">
             <a:spAutoFit/>
           </a:bodyPr>
           <a:lstStyle/>
@@ -4781,7 +4353,7 @@
           <a:noFill/>
         </p:spPr>
         <p:txBody>
-          <a:bodyPr wrap="square" anchor="ctr" lIns="109728" rIns="109728">
+          <a:bodyPr wrap="square" lIns="109728" rIns="109728" anchor="ctr">
             <a:spAutoFit/>
           </a:bodyPr>
           <a:lstStyle/>
@@ -4840,7 +4412,7 @@
           </a:fontRef>
         </p:style>
         <p:txBody>
-          <a:bodyPr rtlCol="0" anchor="ctr" wrap="square" lIns="0" rIns="0"/>
+          <a:bodyPr wrap="square" lIns="0" rIns="0" rtlCol="0" anchor="ctr"/>
           <a:lstStyle/>
           <a:p>
             <a:pPr algn="ctr">
@@ -4901,6 +4473,7 @@
           <a:lstStyle/>
           <a:p>
             <a:pPr algn="ctr"/>
+            <a:endParaRPr/>
           </a:p>
         </p:txBody>
       </p:sp>
@@ -4921,7 +4494,7 @@
           <a:noFill/>
         </p:spPr>
         <p:txBody>
-          <a:bodyPr wrap="square" anchor="ctr" lIns="109728" rIns="109728">
+          <a:bodyPr wrap="square" lIns="109728" rIns="109728" anchor="ctr">
             <a:spAutoFit/>
           </a:bodyPr>
           <a:lstStyle/>
@@ -4986,6 +4559,7 @@
           <a:lstStyle/>
           <a:p>
             <a:pPr algn="ctr"/>
+            <a:endParaRPr/>
           </a:p>
         </p:txBody>
       </p:sp>
@@ -5030,6 +4604,7 @@
           <a:lstStyle/>
           <a:p>
             <a:pPr algn="ctr"/>
+            <a:endParaRPr/>
           </a:p>
         </p:txBody>
       </p:sp>
@@ -5070,7 +4645,7 @@
           </a:fontRef>
         </p:style>
         <p:txBody>
-          <a:bodyPr rtlCol="0" anchor="ctr" wrap="square" lIns="0" rIns="0"/>
+          <a:bodyPr wrap="square" lIns="0" rIns="0" rtlCol="0" anchor="ctr"/>
           <a:lstStyle/>
           <a:p>
             <a:pPr algn="ctr">
@@ -5107,7 +4682,7 @@
           <a:noFill/>
         </p:spPr>
         <p:txBody>
-          <a:bodyPr wrap="square" anchor="ctr" lIns="109728" rIns="109728">
+          <a:bodyPr wrap="square" lIns="109728" rIns="109728" anchor="ctr">
             <a:spAutoFit/>
           </a:bodyPr>
           <a:lstStyle/>
@@ -5146,7 +4721,7 @@
           <a:noFill/>
         </p:spPr>
         <p:txBody>
-          <a:bodyPr wrap="square" anchor="t" lIns="109728" rIns="109728">
+          <a:bodyPr wrap="square" lIns="109728" rIns="109728" anchor="t">
             <a:spAutoFit/>
           </a:bodyPr>
           <a:lstStyle/>
@@ -5211,6 +4786,7 @@
           <a:lstStyle/>
           <a:p>
             <a:pPr algn="ctr"/>
+            <a:endParaRPr/>
           </a:p>
         </p:txBody>
       </p:sp>
@@ -5255,6 +4831,7 @@
           <a:lstStyle/>
           <a:p>
             <a:pPr algn="ctr"/>
+            <a:endParaRPr/>
           </a:p>
         </p:txBody>
       </p:sp>
@@ -5295,7 +4872,7 @@
           </a:fontRef>
         </p:style>
         <p:txBody>
-          <a:bodyPr rtlCol="0" anchor="ctr" wrap="square" lIns="0" rIns="0"/>
+          <a:bodyPr wrap="square" lIns="0" rIns="0" rtlCol="0" anchor="ctr"/>
           <a:lstStyle/>
           <a:p>
             <a:pPr algn="ctr">
@@ -5332,7 +4909,7 @@
           <a:noFill/>
         </p:spPr>
         <p:txBody>
-          <a:bodyPr wrap="square" anchor="ctr" lIns="109728" rIns="109728">
+          <a:bodyPr wrap="square" lIns="109728" rIns="109728" anchor="ctr">
             <a:spAutoFit/>
           </a:bodyPr>
           <a:lstStyle/>
@@ -5371,7 +4948,7 @@
           <a:noFill/>
         </p:spPr>
         <p:txBody>
-          <a:bodyPr wrap="square" anchor="t" lIns="109728" rIns="109728">
+          <a:bodyPr wrap="square" lIns="109728" rIns="109728" anchor="t">
             <a:spAutoFit/>
           </a:bodyPr>
           <a:lstStyle/>
@@ -5436,6 +5013,7 @@
           <a:lstStyle/>
           <a:p>
             <a:pPr algn="ctr"/>
+            <a:endParaRPr/>
           </a:p>
         </p:txBody>
       </p:sp>
@@ -5480,6 +5058,7 @@
           <a:lstStyle/>
           <a:p>
             <a:pPr algn="ctr"/>
+            <a:endParaRPr/>
           </a:p>
         </p:txBody>
       </p:sp>
@@ -5520,7 +5099,7 @@
           </a:fontRef>
         </p:style>
         <p:txBody>
-          <a:bodyPr rtlCol="0" anchor="ctr" wrap="square" lIns="0" rIns="0"/>
+          <a:bodyPr wrap="square" lIns="0" rIns="0" rtlCol="0" anchor="ctr"/>
           <a:lstStyle/>
           <a:p>
             <a:pPr algn="ctr">
@@ -5557,7 +5136,7 @@
           <a:noFill/>
         </p:spPr>
         <p:txBody>
-          <a:bodyPr wrap="square" anchor="ctr" lIns="109728" rIns="109728">
+          <a:bodyPr wrap="square" lIns="109728" rIns="109728" anchor="ctr">
             <a:spAutoFit/>
           </a:bodyPr>
           <a:lstStyle/>
@@ -5596,7 +5175,7 @@
           <a:noFill/>
         </p:spPr>
         <p:txBody>
-          <a:bodyPr wrap="square" anchor="t" lIns="109728" rIns="109728">
+          <a:bodyPr wrap="square" lIns="109728" rIns="109728" anchor="t">
             <a:spAutoFit/>
           </a:bodyPr>
           <a:lstStyle/>
@@ -5661,6 +5240,7 @@
           <a:lstStyle/>
           <a:p>
             <a:pPr algn="ctr"/>
+            <a:endParaRPr/>
           </a:p>
         </p:txBody>
       </p:sp>
@@ -5705,6 +5285,7 @@
           <a:lstStyle/>
           <a:p>
             <a:pPr algn="ctr"/>
+            <a:endParaRPr/>
           </a:p>
         </p:txBody>
       </p:sp>
@@ -5745,7 +5326,7 @@
           </a:fontRef>
         </p:style>
         <p:txBody>
-          <a:bodyPr rtlCol="0" anchor="ctr" wrap="square" lIns="0" rIns="0"/>
+          <a:bodyPr wrap="square" lIns="0" rIns="0" rtlCol="0" anchor="ctr"/>
           <a:lstStyle/>
           <a:p>
             <a:pPr algn="ctr">
@@ -5782,7 +5363,7 @@
           <a:noFill/>
         </p:spPr>
         <p:txBody>
-          <a:bodyPr wrap="square" anchor="ctr" lIns="109728" rIns="109728">
+          <a:bodyPr wrap="square" lIns="109728" rIns="109728" anchor="ctr">
             <a:spAutoFit/>
           </a:bodyPr>
           <a:lstStyle/>
@@ -5821,7 +5402,7 @@
           <a:noFill/>
         </p:spPr>
         <p:txBody>
-          <a:bodyPr wrap="square" anchor="t" lIns="109728" rIns="109728">
+          <a:bodyPr wrap="square" lIns="109728" rIns="109728" anchor="t">
             <a:spAutoFit/>
           </a:bodyPr>
           <a:lstStyle/>
@@ -5886,6 +5467,7 @@
           <a:lstStyle/>
           <a:p>
             <a:pPr algn="ctr"/>
+            <a:endParaRPr/>
           </a:p>
         </p:txBody>
       </p:sp>
@@ -5930,6 +5512,7 @@
           <a:lstStyle/>
           <a:p>
             <a:pPr algn="ctr"/>
+            <a:endParaRPr/>
           </a:p>
         </p:txBody>
       </p:sp>
@@ -5970,7 +5553,7 @@
           </a:fontRef>
         </p:style>
         <p:txBody>
-          <a:bodyPr rtlCol="0" anchor="ctr" wrap="square" lIns="0" rIns="0"/>
+          <a:bodyPr wrap="square" lIns="0" rIns="0" rtlCol="0" anchor="ctr"/>
           <a:lstStyle/>
           <a:p>
             <a:pPr algn="ctr">
@@ -6007,7 +5590,7 @@
           <a:noFill/>
         </p:spPr>
         <p:txBody>
-          <a:bodyPr wrap="square" anchor="ctr" lIns="109728" rIns="109728">
+          <a:bodyPr wrap="square" lIns="109728" rIns="109728" anchor="ctr">
             <a:spAutoFit/>
           </a:bodyPr>
           <a:lstStyle/>
@@ -6046,7 +5629,7 @@
           <a:noFill/>
         </p:spPr>
         <p:txBody>
-          <a:bodyPr wrap="square" anchor="t" lIns="109728" rIns="109728">
+          <a:bodyPr wrap="square" lIns="109728" rIns="109728" anchor="t">
             <a:spAutoFit/>
           </a:bodyPr>
           <a:lstStyle/>
@@ -6111,6 +5694,7 @@
           <a:lstStyle/>
           <a:p>
             <a:pPr algn="ctr"/>
+            <a:endParaRPr/>
           </a:p>
         </p:txBody>
       </p:sp>
@@ -6155,6 +5739,7 @@
           <a:lstStyle/>
           <a:p>
             <a:pPr algn="ctr"/>
+            <a:endParaRPr/>
           </a:p>
         </p:txBody>
       </p:sp>
@@ -6195,7 +5780,7 @@
           </a:fontRef>
         </p:style>
         <p:txBody>
-          <a:bodyPr rtlCol="0" anchor="ctr" wrap="square" lIns="0" rIns="0"/>
+          <a:bodyPr wrap="square" lIns="0" rIns="0" rtlCol="0" anchor="ctr"/>
           <a:lstStyle/>
           <a:p>
             <a:pPr algn="ctr">
@@ -6232,7 +5817,7 @@
           <a:noFill/>
         </p:spPr>
         <p:txBody>
-          <a:bodyPr wrap="square" anchor="ctr" lIns="109728" rIns="109728">
+          <a:bodyPr wrap="square" lIns="109728" rIns="109728" anchor="ctr">
             <a:spAutoFit/>
           </a:bodyPr>
           <a:lstStyle/>
@@ -6271,7 +5856,7 @@
           <a:noFill/>
         </p:spPr>
         <p:txBody>
-          <a:bodyPr wrap="square" anchor="t" lIns="109728" rIns="109728">
+          <a:bodyPr wrap="square" lIns="109728" rIns="109728" anchor="t">
             <a:spAutoFit/>
           </a:bodyPr>
           <a:lstStyle/>
@@ -6336,6 +5921,7 @@
           <a:lstStyle/>
           <a:p>
             <a:pPr algn="ctr"/>
+            <a:endParaRPr/>
           </a:p>
         </p:txBody>
       </p:sp>
@@ -6380,6 +5966,7 @@
           <a:lstStyle/>
           <a:p>
             <a:pPr algn="ctr"/>
+            <a:endParaRPr/>
           </a:p>
         </p:txBody>
       </p:sp>
@@ -6420,7 +6007,7 @@
           </a:fontRef>
         </p:style>
         <p:txBody>
-          <a:bodyPr rtlCol="0" anchor="ctr" wrap="square" lIns="0" rIns="0"/>
+          <a:bodyPr wrap="square" lIns="0" rIns="0" rtlCol="0" anchor="ctr"/>
           <a:lstStyle/>
           <a:p>
             <a:pPr algn="ctr">
@@ -6457,7 +6044,7 @@
           <a:noFill/>
         </p:spPr>
         <p:txBody>
-          <a:bodyPr wrap="square" anchor="ctr" lIns="109728" rIns="109728">
+          <a:bodyPr wrap="square" lIns="109728" rIns="109728" anchor="ctr">
             <a:spAutoFit/>
           </a:bodyPr>
           <a:lstStyle/>
@@ -6496,7 +6083,7 @@
           <a:noFill/>
         </p:spPr>
         <p:txBody>
-          <a:bodyPr wrap="square" anchor="t" lIns="109728" rIns="109728">
+          <a:bodyPr wrap="square" lIns="109728" rIns="109728" anchor="t">
             <a:spAutoFit/>
           </a:bodyPr>
           <a:lstStyle/>
@@ -6557,7 +6144,7 @@
           </a:fontRef>
         </p:style>
         <p:txBody>
-          <a:bodyPr rtlCol="0" anchor="ctr" wrap="square" lIns="182880" rIns="182880"/>
+          <a:bodyPr wrap="square" lIns="182880" rIns="182880" rtlCol="0" anchor="ctr"/>
           <a:lstStyle/>
           <a:p>
             <a:pPr algn="l">
@@ -6610,7 +6197,7 @@
           <a:noFill/>
         </p:spPr>
         <p:txBody>
-          <a:bodyPr wrap="square" anchor="ctr" lIns="109728" rIns="109728">
+          <a:bodyPr wrap="square" lIns="109728" rIns="109728" anchor="ctr">
             <a:spAutoFit/>
           </a:bodyPr>
           <a:lstStyle/>
@@ -6641,7 +6228,7 @@
 </file>
 
 <file path=ppt/slides/slide3.xml><?xml version="1.0" encoding="utf-8"?>
-<p:sld xmlns:a="http://schemas.openxmlformats.org/drawingml/2006/main" xmlns:p="http://schemas.openxmlformats.org/presentationml/2006/main" xmlns:r="http://schemas.openxmlformats.org/officeDocument/2006/relationships">
+<p:sld xmlns:a="http://schemas.openxmlformats.org/drawingml/2006/main" xmlns:r="http://schemas.openxmlformats.org/officeDocument/2006/relationships" xmlns:p="http://schemas.openxmlformats.org/presentationml/2006/main">
   <p:cSld>
     <p:spTree>
       <p:nvGrpSpPr>
@@ -6649,7 +6236,14 @@
         <p:cNvGrpSpPr/>
         <p:nvPr/>
       </p:nvGrpSpPr>
-      <p:grpSpPr/>
+      <p:grpSpPr>
+        <a:xfrm>
+          <a:off x="0" y="0"/>
+          <a:ext cx="0" cy="0"/>
+          <a:chOff x="0" y="0"/>
+          <a:chExt cx="0" cy="0"/>
+        </a:xfrm>
+      </p:grpSpPr>
       <p:sp>
         <p:nvSpPr>
           <p:cNvPr id="2" name="Rectangle 1"/>
@@ -6691,6 +6285,7 @@
           <a:lstStyle/>
           <a:p>
             <a:pPr algn="ctr"/>
+            <a:endParaRPr/>
           </a:p>
         </p:txBody>
       </p:sp>
@@ -6735,6 +6330,7 @@
           <a:lstStyle/>
           <a:p>
             <a:pPr algn="ctr"/>
+            <a:endParaRPr/>
           </a:p>
         </p:txBody>
       </p:sp>
@@ -6755,7 +6351,7 @@
           <a:noFill/>
         </p:spPr>
         <p:txBody>
-          <a:bodyPr wrap="square" anchor="ctr" lIns="109728" rIns="109728">
+          <a:bodyPr wrap="square" lIns="109728" rIns="109728" anchor="ctr">
             <a:spAutoFit/>
           </a:bodyPr>
           <a:lstStyle/>
@@ -6794,7 +6390,7 @@
           <a:noFill/>
         </p:spPr>
         <p:txBody>
-          <a:bodyPr wrap="square" anchor="ctr" lIns="109728" rIns="109728">
+          <a:bodyPr wrap="square" lIns="109728" rIns="109728" anchor="ctr">
             <a:spAutoFit/>
           </a:bodyPr>
           <a:lstStyle/>
@@ -6853,7 +6449,7 @@
           </a:fontRef>
         </p:style>
         <p:txBody>
-          <a:bodyPr rtlCol="0" anchor="ctr" wrap="square" lIns="0" rIns="0"/>
+          <a:bodyPr wrap="square" lIns="0" rIns="0" rtlCol="0" anchor="ctr"/>
           <a:lstStyle/>
           <a:p>
             <a:pPr algn="ctr">
@@ -6914,6 +6510,7 @@
           <a:lstStyle/>
           <a:p>
             <a:pPr algn="ctr"/>
+            <a:endParaRPr/>
           </a:p>
         </p:txBody>
       </p:sp>
@@ -6934,7 +6531,7 @@
           <a:noFill/>
         </p:spPr>
         <p:txBody>
-          <a:bodyPr wrap="square" anchor="ctr" lIns="109728" rIns="109728">
+          <a:bodyPr wrap="square" lIns="109728" rIns="109728" anchor="ctr">
             <a:spAutoFit/>
           </a:bodyPr>
           <a:lstStyle/>
@@ -6975,13 +6572,25 @@
                 <a:tableStyleId>{5C22544A-7EE6-4342-B048-85BDC9FD1C3A}</a:tableStyleId>
               </a:tblPr>
               <a:tblGrid>
-                <a:gridCol w="3200400"/>
-                <a:gridCol w="7891272"/>
+                <a:gridCol w="3200400">
+                  <a:extLst>
+                    <a:ext uri="{9D8B030D-6E8A-4147-A177-3AD203B41FA5}">
+                      <a16:colId xmlns:a16="http://schemas.microsoft.com/office/drawing/2014/main" val="20000"/>
+                    </a:ext>
+                  </a:extLst>
+                </a:gridCol>
+                <a:gridCol w="7891272">
+                  <a:extLst>
+                    <a:ext uri="{9D8B030D-6E8A-4147-A177-3AD203B41FA5}">
+                      <a16:colId xmlns:a16="http://schemas.microsoft.com/office/drawing/2014/main" val="20001"/>
+                    </a:ext>
+                  </a:extLst>
+                </a:gridCol>
               </a:tblGrid>
               <a:tr h="374904">
                 <a:tc>
                   <a:txBody>
-                    <a:bodyPr wrap="square" anchor="ctr" lIns="109728" rIns="109728"/>
+                    <a:bodyPr/>
                     <a:lstStyle/>
                     <a:p>
                       <a:pPr algn="l">
@@ -7008,7 +6617,7 @@
                 </a:tc>
                 <a:tc>
                   <a:txBody>
-                    <a:bodyPr wrap="square" anchor="ctr" lIns="109728" rIns="109728"/>
+                    <a:bodyPr/>
                     <a:lstStyle/>
                     <a:p>
                       <a:pPr algn="l">
@@ -7033,11 +6642,16 @@
                     </a:solidFill>
                   </a:tcPr>
                 </a:tc>
+                <a:extLst>
+                  <a:ext uri="{0D108BD9-81ED-4DB2-BD59-A6C34878D82A}">
+                    <a16:rowId xmlns:a16="http://schemas.microsoft.com/office/drawing/2014/main" val="10000"/>
+                  </a:ext>
+                </a:extLst>
               </a:tr>
               <a:tr h="374904">
                 <a:tc>
                   <a:txBody>
-                    <a:bodyPr wrap="square" anchor="ctr" lIns="109728" rIns="109728"/>
+                    <a:bodyPr/>
                     <a:lstStyle/>
                     <a:p>
                       <a:pPr algn="l">
@@ -7064,7 +6678,7 @@
                 </a:tc>
                 <a:tc>
                   <a:txBody>
-                    <a:bodyPr wrap="square" anchor="ctr" lIns="109728" rIns="109728"/>
+                    <a:bodyPr/>
                     <a:lstStyle/>
                     <a:p>
                       <a:pPr algn="l">
@@ -7089,11 +6703,16 @@
                     </a:solidFill>
                   </a:tcPr>
                 </a:tc>
+                <a:extLst>
+                  <a:ext uri="{0D108BD9-81ED-4DB2-BD59-A6C34878D82A}">
+                    <a16:rowId xmlns:a16="http://schemas.microsoft.com/office/drawing/2014/main" val="10001"/>
+                  </a:ext>
+                </a:extLst>
               </a:tr>
               <a:tr h="374904">
                 <a:tc>
                   <a:txBody>
-                    <a:bodyPr wrap="square" anchor="ctr" lIns="109728" rIns="109728"/>
+                    <a:bodyPr/>
                     <a:lstStyle/>
                     <a:p>
                       <a:pPr algn="l">
@@ -7120,7 +6739,7 @@
                 </a:tc>
                 <a:tc>
                   <a:txBody>
-                    <a:bodyPr wrap="square" anchor="ctr" lIns="109728" rIns="109728"/>
+                    <a:bodyPr/>
                     <a:lstStyle/>
                     <a:p>
                       <a:pPr algn="l">
@@ -7145,11 +6764,16 @@
                     </a:solidFill>
                   </a:tcPr>
                 </a:tc>
+                <a:extLst>
+                  <a:ext uri="{0D108BD9-81ED-4DB2-BD59-A6C34878D82A}">
+                    <a16:rowId xmlns:a16="http://schemas.microsoft.com/office/drawing/2014/main" val="10002"/>
+                  </a:ext>
+                </a:extLst>
               </a:tr>
               <a:tr h="374904">
                 <a:tc>
                   <a:txBody>
-                    <a:bodyPr wrap="square" anchor="ctr" lIns="109728" rIns="109728"/>
+                    <a:bodyPr/>
                     <a:lstStyle/>
                     <a:p>
                       <a:pPr algn="l">
@@ -7176,7 +6800,7 @@
                 </a:tc>
                 <a:tc>
                   <a:txBody>
-                    <a:bodyPr wrap="square" anchor="ctr" lIns="109728" rIns="109728"/>
+                    <a:bodyPr/>
                     <a:lstStyle/>
                     <a:p>
                       <a:pPr algn="l">
@@ -7201,11 +6825,16 @@
                     </a:solidFill>
                   </a:tcPr>
                 </a:tc>
+                <a:extLst>
+                  <a:ext uri="{0D108BD9-81ED-4DB2-BD59-A6C34878D82A}">
+                    <a16:rowId xmlns:a16="http://schemas.microsoft.com/office/drawing/2014/main" val="10003"/>
+                  </a:ext>
+                </a:extLst>
               </a:tr>
               <a:tr h="374904">
                 <a:tc>
                   <a:txBody>
-                    <a:bodyPr wrap="square" anchor="ctr" lIns="109728" rIns="109728"/>
+                    <a:bodyPr/>
                     <a:lstStyle/>
                     <a:p>
                       <a:pPr algn="l">
@@ -7232,7 +6861,7 @@
                 </a:tc>
                 <a:tc>
                   <a:txBody>
-                    <a:bodyPr wrap="square" anchor="ctr" lIns="109728" rIns="109728"/>
+                    <a:bodyPr/>
                     <a:lstStyle/>
                     <a:p>
                       <a:pPr algn="l">
@@ -7257,11 +6886,16 @@
                     </a:solidFill>
                   </a:tcPr>
                 </a:tc>
+                <a:extLst>
+                  <a:ext uri="{0D108BD9-81ED-4DB2-BD59-A6C34878D82A}">
+                    <a16:rowId xmlns:a16="http://schemas.microsoft.com/office/drawing/2014/main" val="10004"/>
+                  </a:ext>
+                </a:extLst>
               </a:tr>
               <a:tr h="374904">
                 <a:tc>
                   <a:txBody>
-                    <a:bodyPr wrap="square" anchor="ctr" lIns="109728" rIns="109728"/>
+                    <a:bodyPr/>
                     <a:lstStyle/>
                     <a:p>
                       <a:pPr algn="l">
@@ -7288,7 +6922,7 @@
                 </a:tc>
                 <a:tc>
                   <a:txBody>
-                    <a:bodyPr wrap="square" anchor="ctr" lIns="109728" rIns="109728"/>
+                    <a:bodyPr/>
                     <a:lstStyle/>
                     <a:p>
                       <a:pPr algn="l">
@@ -7313,11 +6947,16 @@
                     </a:solidFill>
                   </a:tcPr>
                 </a:tc>
+                <a:extLst>
+                  <a:ext uri="{0D108BD9-81ED-4DB2-BD59-A6C34878D82A}">
+                    <a16:rowId xmlns:a16="http://schemas.microsoft.com/office/drawing/2014/main" val="10005"/>
+                  </a:ext>
+                </a:extLst>
               </a:tr>
               <a:tr h="374904">
                 <a:tc>
                   <a:txBody>
-                    <a:bodyPr wrap="square" anchor="ctr" lIns="109728" rIns="109728"/>
+                    <a:bodyPr/>
                     <a:lstStyle/>
                     <a:p>
                       <a:pPr algn="l">
@@ -7344,7 +6983,7 @@
                 </a:tc>
                 <a:tc>
                   <a:txBody>
-                    <a:bodyPr wrap="square" anchor="ctr" lIns="109728" rIns="109728"/>
+                    <a:bodyPr/>
                     <a:lstStyle/>
                     <a:p>
                       <a:pPr algn="l">
@@ -7369,11 +7008,16 @@
                     </a:solidFill>
                   </a:tcPr>
                 </a:tc>
+                <a:extLst>
+                  <a:ext uri="{0D108BD9-81ED-4DB2-BD59-A6C34878D82A}">
+                    <a16:rowId xmlns:a16="http://schemas.microsoft.com/office/drawing/2014/main" val="10006"/>
+                  </a:ext>
+                </a:extLst>
               </a:tr>
               <a:tr h="374904">
                 <a:tc>
                   <a:txBody>
-                    <a:bodyPr wrap="square" anchor="ctr" lIns="109728" rIns="109728"/>
+                    <a:bodyPr/>
                     <a:lstStyle/>
                     <a:p>
                       <a:pPr algn="l">
@@ -7400,7 +7044,7 @@
                 </a:tc>
                 <a:tc>
                   <a:txBody>
-                    <a:bodyPr wrap="square" anchor="ctr" lIns="109728" rIns="109728"/>
+                    <a:bodyPr/>
                     <a:lstStyle/>
                     <a:p>
                       <a:pPr algn="l">
@@ -7425,11 +7069,16 @@
                     </a:solidFill>
                   </a:tcPr>
                 </a:tc>
+                <a:extLst>
+                  <a:ext uri="{0D108BD9-81ED-4DB2-BD59-A6C34878D82A}">
+                    <a16:rowId xmlns:a16="http://schemas.microsoft.com/office/drawing/2014/main" val="10007"/>
+                  </a:ext>
+                </a:extLst>
               </a:tr>
               <a:tr h="374904">
                 <a:tc>
                   <a:txBody>
-                    <a:bodyPr wrap="square" anchor="ctr" lIns="109728" rIns="109728"/>
+                    <a:bodyPr/>
                     <a:lstStyle/>
                     <a:p>
                       <a:pPr algn="l">
@@ -7456,7 +7105,7 @@
                 </a:tc>
                 <a:tc>
                   <a:txBody>
-                    <a:bodyPr wrap="square" anchor="ctr" lIns="109728" rIns="109728"/>
+                    <a:bodyPr/>
                     <a:lstStyle/>
                     <a:p>
                       <a:pPr algn="l">
@@ -7481,11 +7130,16 @@
                     </a:solidFill>
                   </a:tcPr>
                 </a:tc>
+                <a:extLst>
+                  <a:ext uri="{0D108BD9-81ED-4DB2-BD59-A6C34878D82A}">
+                    <a16:rowId xmlns:a16="http://schemas.microsoft.com/office/drawing/2014/main" val="10008"/>
+                  </a:ext>
+                </a:extLst>
               </a:tr>
               <a:tr h="374904">
                 <a:tc>
                   <a:txBody>
-                    <a:bodyPr wrap="square" anchor="ctr" lIns="109728" rIns="109728"/>
+                    <a:bodyPr/>
                     <a:lstStyle/>
                     <a:p>
                       <a:pPr algn="l">
@@ -7512,7 +7166,7 @@
                 </a:tc>
                 <a:tc>
                   <a:txBody>
-                    <a:bodyPr wrap="square" anchor="ctr" lIns="109728" rIns="109728"/>
+                    <a:bodyPr/>
                     <a:lstStyle/>
                     <a:p>
                       <a:pPr algn="l">
@@ -7537,11 +7191,16 @@
                     </a:solidFill>
                   </a:tcPr>
                 </a:tc>
+                <a:extLst>
+                  <a:ext uri="{0D108BD9-81ED-4DB2-BD59-A6C34878D82A}">
+                    <a16:rowId xmlns:a16="http://schemas.microsoft.com/office/drawing/2014/main" val="10009"/>
+                  </a:ext>
+                </a:extLst>
               </a:tr>
               <a:tr h="374904">
                 <a:tc>
                   <a:txBody>
-                    <a:bodyPr wrap="square" anchor="ctr" lIns="109728" rIns="109728"/>
+                    <a:bodyPr/>
                     <a:lstStyle/>
                     <a:p>
                       <a:pPr algn="l">
@@ -7568,7 +7227,7 @@
                 </a:tc>
                 <a:tc>
                   <a:txBody>
-                    <a:bodyPr wrap="square" anchor="ctr" lIns="109728" rIns="109728"/>
+                    <a:bodyPr/>
                     <a:lstStyle/>
                     <a:p>
                       <a:pPr algn="l">
@@ -7593,11 +7252,16 @@
                     </a:solidFill>
                   </a:tcPr>
                 </a:tc>
+                <a:extLst>
+                  <a:ext uri="{0D108BD9-81ED-4DB2-BD59-A6C34878D82A}">
+                    <a16:rowId xmlns:a16="http://schemas.microsoft.com/office/drawing/2014/main" val="10010"/>
+                  </a:ext>
+                </a:extLst>
               </a:tr>
               <a:tr h="374904">
                 <a:tc>
                   <a:txBody>
-                    <a:bodyPr wrap="square" anchor="ctr" lIns="109728" rIns="109728"/>
+                    <a:bodyPr/>
                     <a:lstStyle/>
                     <a:p>
                       <a:pPr algn="l">
@@ -7624,7 +7288,7 @@
                 </a:tc>
                 <a:tc>
                   <a:txBody>
-                    <a:bodyPr wrap="square" anchor="ctr" lIns="109728" rIns="109728"/>
+                    <a:bodyPr/>
                     <a:lstStyle/>
                     <a:p>
                       <a:pPr algn="l">
@@ -7649,11 +7313,16 @@
                     </a:solidFill>
                   </a:tcPr>
                 </a:tc>
+                <a:extLst>
+                  <a:ext uri="{0D108BD9-81ED-4DB2-BD59-A6C34878D82A}">
+                    <a16:rowId xmlns:a16="http://schemas.microsoft.com/office/drawing/2014/main" val="10011"/>
+                  </a:ext>
+                </a:extLst>
               </a:tr>
               <a:tr h="374904">
                 <a:tc>
                   <a:txBody>
-                    <a:bodyPr wrap="square" anchor="ctr" lIns="109728" rIns="109728"/>
+                    <a:bodyPr/>
                     <a:lstStyle/>
                     <a:p>
                       <a:pPr algn="l">
@@ -7680,7 +7349,7 @@
                 </a:tc>
                 <a:tc>
                   <a:txBody>
-                    <a:bodyPr wrap="square" anchor="ctr" lIns="109728" rIns="109728"/>
+                    <a:bodyPr/>
                     <a:lstStyle/>
                     <a:p>
                       <a:pPr algn="l">
@@ -7705,6 +7374,11 @@
                     </a:solidFill>
                   </a:tcPr>
                 </a:tc>
+                <a:extLst>
+                  <a:ext uri="{0D108BD9-81ED-4DB2-BD59-A6C34878D82A}">
+                    <a16:rowId xmlns:a16="http://schemas.microsoft.com/office/drawing/2014/main" val="10012"/>
+                  </a:ext>
+                </a:extLst>
               </a:tr>
             </a:tbl>
           </a:graphicData>
@@ -7719,7 +7393,7 @@
 </file>
 
 <file path=ppt/slides/slide4.xml><?xml version="1.0" encoding="utf-8"?>
-<p:sld xmlns:a="http://schemas.openxmlformats.org/drawingml/2006/main" xmlns:p="http://schemas.openxmlformats.org/presentationml/2006/main" xmlns:r="http://schemas.openxmlformats.org/officeDocument/2006/relationships">
+<p:sld xmlns:a="http://schemas.openxmlformats.org/drawingml/2006/main" xmlns:r="http://schemas.openxmlformats.org/officeDocument/2006/relationships" xmlns:p="http://schemas.openxmlformats.org/presentationml/2006/main">
   <p:cSld>
     <p:spTree>
       <p:nvGrpSpPr>
@@ -7727,7 +7401,14 @@
         <p:cNvGrpSpPr/>
         <p:nvPr/>
       </p:nvGrpSpPr>
-      <p:grpSpPr/>
+      <p:grpSpPr>
+        <a:xfrm>
+          <a:off x="0" y="0"/>
+          <a:ext cx="0" cy="0"/>
+          <a:chOff x="0" y="0"/>
+          <a:chExt cx="0" cy="0"/>
+        </a:xfrm>
+      </p:grpSpPr>
       <p:sp>
         <p:nvSpPr>
           <p:cNvPr id="2" name="Rectangle 1"/>
@@ -7769,6 +7450,7 @@
           <a:lstStyle/>
           <a:p>
             <a:pPr algn="ctr"/>
+            <a:endParaRPr/>
           </a:p>
         </p:txBody>
       </p:sp>
@@ -7813,6 +7495,7 @@
           <a:lstStyle/>
           <a:p>
             <a:pPr algn="ctr"/>
+            <a:endParaRPr/>
           </a:p>
         </p:txBody>
       </p:sp>
@@ -7833,7 +7516,7 @@
           <a:noFill/>
         </p:spPr>
         <p:txBody>
-          <a:bodyPr wrap="square" anchor="ctr" lIns="109728" rIns="109728">
+          <a:bodyPr wrap="square" lIns="109728" rIns="109728" anchor="ctr">
             <a:spAutoFit/>
           </a:bodyPr>
           <a:lstStyle/>
@@ -7872,7 +7555,7 @@
           <a:noFill/>
         </p:spPr>
         <p:txBody>
-          <a:bodyPr wrap="square" anchor="ctr" lIns="109728" rIns="109728">
+          <a:bodyPr wrap="square" lIns="109728" rIns="109728" anchor="ctr">
             <a:spAutoFit/>
           </a:bodyPr>
           <a:lstStyle/>
@@ -7931,7 +7614,7 @@
           </a:fontRef>
         </p:style>
         <p:txBody>
-          <a:bodyPr rtlCol="0" anchor="ctr" wrap="square" lIns="0" rIns="0"/>
+          <a:bodyPr wrap="square" lIns="0" rIns="0" rtlCol="0" anchor="ctr"/>
           <a:lstStyle/>
           <a:p>
             <a:pPr algn="ctr">
@@ -7992,6 +7675,7 @@
           <a:lstStyle/>
           <a:p>
             <a:pPr algn="ctr"/>
+            <a:endParaRPr/>
           </a:p>
         </p:txBody>
       </p:sp>
@@ -8012,7 +7696,7 @@
           <a:noFill/>
         </p:spPr>
         <p:txBody>
-          <a:bodyPr wrap="square" anchor="ctr" lIns="109728" rIns="109728">
+          <a:bodyPr wrap="square" lIns="109728" rIns="109728" anchor="ctr">
             <a:spAutoFit/>
           </a:bodyPr>
           <a:lstStyle/>
@@ -8077,6 +7761,7 @@
           <a:lstStyle/>
           <a:p>
             <a:pPr algn="ctr"/>
+            <a:endParaRPr/>
           </a:p>
         </p:txBody>
       </p:sp>
@@ -8097,7 +7782,7 @@
           <a:noFill/>
         </p:spPr>
         <p:txBody>
-          <a:bodyPr wrap="square" anchor="ctr" lIns="109728" rIns="109728">
+          <a:bodyPr wrap="square" lIns="109728" rIns="109728" anchor="ctr">
             <a:spAutoFit/>
           </a:bodyPr>
           <a:lstStyle/>
@@ -8158,7 +7843,7 @@
           </a:fontRef>
         </p:style>
         <p:txBody>
-          <a:bodyPr rtlCol="0" anchor="ctr" wrap="square" lIns="45720" rIns="45720"/>
+          <a:bodyPr wrap="square" lIns="45720" rIns="45720" rtlCol="0" anchor="ctr"/>
           <a:lstStyle/>
           <a:p>
             <a:pPr algn="ctr">
@@ -8195,7 +7880,7 @@
           <a:noFill/>
         </p:spPr>
         <p:txBody>
-          <a:bodyPr wrap="square" anchor="t" lIns="109728" rIns="109728">
+          <a:bodyPr wrap="square" lIns="109728" rIns="109728" anchor="t">
             <a:spAutoFit/>
           </a:bodyPr>
           <a:lstStyle/>
@@ -8256,7 +7941,7 @@
           </a:fontRef>
         </p:style>
         <p:txBody>
-          <a:bodyPr rtlCol="0" anchor="ctr" wrap="square" lIns="45720" rIns="45720"/>
+          <a:bodyPr wrap="square" lIns="45720" rIns="45720" rtlCol="0" anchor="ctr"/>
           <a:lstStyle/>
           <a:p>
             <a:pPr algn="ctr">
@@ -8293,7 +7978,7 @@
           <a:noFill/>
         </p:spPr>
         <p:txBody>
-          <a:bodyPr wrap="square" anchor="t" lIns="109728" rIns="109728">
+          <a:bodyPr wrap="square" lIns="109728" rIns="109728" anchor="t">
             <a:spAutoFit/>
           </a:bodyPr>
           <a:lstStyle/>
@@ -8354,7 +8039,7 @@
           </a:fontRef>
         </p:style>
         <p:txBody>
-          <a:bodyPr rtlCol="0" anchor="ctr" wrap="square" lIns="45720" rIns="45720"/>
+          <a:bodyPr wrap="square" lIns="45720" rIns="45720" rtlCol="0" anchor="ctr"/>
           <a:lstStyle/>
           <a:p>
             <a:pPr algn="ctr">
@@ -8391,7 +8076,7 @@
           <a:noFill/>
         </p:spPr>
         <p:txBody>
-          <a:bodyPr wrap="square" anchor="t" lIns="109728" rIns="109728">
+          <a:bodyPr wrap="square" lIns="109728" rIns="109728" anchor="t">
             <a:spAutoFit/>
           </a:bodyPr>
           <a:lstStyle/>
@@ -8452,7 +8137,7 @@
           </a:fontRef>
         </p:style>
         <p:txBody>
-          <a:bodyPr rtlCol="0" anchor="ctr" wrap="square" lIns="45720" rIns="45720"/>
+          <a:bodyPr wrap="square" lIns="45720" rIns="45720" rtlCol="0" anchor="ctr"/>
           <a:lstStyle/>
           <a:p>
             <a:pPr algn="ctr">
@@ -8489,7 +8174,7 @@
           <a:noFill/>
         </p:spPr>
         <p:txBody>
-          <a:bodyPr wrap="square" anchor="t" lIns="109728" rIns="109728">
+          <a:bodyPr wrap="square" lIns="109728" rIns="109728" anchor="t">
             <a:spAutoFit/>
           </a:bodyPr>
           <a:lstStyle/>
@@ -8554,6 +8239,7 @@
           <a:lstStyle/>
           <a:p>
             <a:pPr algn="ctr"/>
+            <a:endParaRPr/>
           </a:p>
         </p:txBody>
       </p:sp>
@@ -8574,7 +8260,7 @@
           <a:noFill/>
         </p:spPr>
         <p:txBody>
-          <a:bodyPr wrap="square" anchor="ctr" lIns="109728" rIns="109728">
+          <a:bodyPr wrap="square" lIns="109728" rIns="109728" anchor="ctr">
             <a:spAutoFit/>
           </a:bodyPr>
           <a:lstStyle/>
@@ -8613,7 +8299,7 @@
           <a:noFill/>
         </p:spPr>
         <p:txBody>
-          <a:bodyPr wrap="square" anchor="t" lIns="109728" rIns="109728">
+          <a:bodyPr wrap="square" lIns="109728" rIns="109728" anchor="t">
             <a:spAutoFit/>
           </a:bodyPr>
           <a:lstStyle/>
@@ -8822,6 +8508,7 @@
           <a:lstStyle/>
           <a:p>
             <a:pPr algn="ctr"/>
+            <a:endParaRPr/>
           </a:p>
         </p:txBody>
       </p:sp>
@@ -8842,7 +8529,7 @@
           <a:noFill/>
         </p:spPr>
         <p:txBody>
-          <a:bodyPr wrap="square" anchor="ctr" lIns="109728" rIns="109728">
+          <a:bodyPr wrap="square" lIns="109728" rIns="109728" anchor="ctr">
             <a:spAutoFit/>
           </a:bodyPr>
           <a:lstStyle/>
@@ -8903,7 +8590,7 @@
           </a:fontRef>
         </p:style>
         <p:txBody>
-          <a:bodyPr rtlCol="0" anchor="ctr" wrap="square" lIns="18288" rIns="18288"/>
+          <a:bodyPr wrap="square" lIns="18288" rIns="18288" rtlCol="0" anchor="ctr"/>
           <a:lstStyle/>
           <a:p>
             <a:pPr algn="ctr">
@@ -8940,7 +8627,7 @@
           <a:noFill/>
         </p:spPr>
         <p:txBody>
-          <a:bodyPr wrap="square" anchor="ctr" lIns="109728" rIns="109728">
+          <a:bodyPr wrap="square" lIns="109728" rIns="109728" anchor="ctr">
             <a:spAutoFit/>
           </a:bodyPr>
           <a:lstStyle/>
@@ -8979,7 +8666,7 @@
           <a:noFill/>
         </p:spPr>
         <p:txBody>
-          <a:bodyPr wrap="square" anchor="t" lIns="109728" rIns="109728">
+          <a:bodyPr wrap="square" lIns="109728" rIns="109728" anchor="t">
             <a:spAutoFit/>
           </a:bodyPr>
           <a:lstStyle/>
@@ -9040,7 +8727,7 @@
           </a:fontRef>
         </p:style>
         <p:txBody>
-          <a:bodyPr rtlCol="0" anchor="ctr" wrap="square" lIns="18288" rIns="18288"/>
+          <a:bodyPr wrap="square" lIns="18288" rIns="18288" rtlCol="0" anchor="ctr"/>
           <a:lstStyle/>
           <a:p>
             <a:pPr algn="ctr">
@@ -9077,7 +8764,7 @@
           <a:noFill/>
         </p:spPr>
         <p:txBody>
-          <a:bodyPr wrap="square" anchor="ctr" lIns="109728" rIns="109728">
+          <a:bodyPr wrap="square" lIns="109728" rIns="109728" anchor="ctr">
             <a:spAutoFit/>
           </a:bodyPr>
           <a:lstStyle/>
@@ -9116,7 +8803,7 @@
           <a:noFill/>
         </p:spPr>
         <p:txBody>
-          <a:bodyPr wrap="square" anchor="t" lIns="109728" rIns="109728">
+          <a:bodyPr wrap="square" lIns="109728" rIns="109728" anchor="t">
             <a:spAutoFit/>
           </a:bodyPr>
           <a:lstStyle/>
@@ -9177,7 +8864,7 @@
           </a:fontRef>
         </p:style>
         <p:txBody>
-          <a:bodyPr rtlCol="0" anchor="ctr" wrap="square" lIns="18288" rIns="18288"/>
+          <a:bodyPr wrap="square" lIns="18288" rIns="18288" rtlCol="0" anchor="ctr"/>
           <a:lstStyle/>
           <a:p>
             <a:pPr algn="ctr">
@@ -9214,7 +8901,7 @@
           <a:noFill/>
         </p:spPr>
         <p:txBody>
-          <a:bodyPr wrap="square" anchor="ctr" lIns="109728" rIns="109728">
+          <a:bodyPr wrap="square" lIns="109728" rIns="109728" anchor="ctr">
             <a:spAutoFit/>
           </a:bodyPr>
           <a:lstStyle/>
@@ -9253,7 +8940,7 @@
           <a:noFill/>
         </p:spPr>
         <p:txBody>
-          <a:bodyPr wrap="square" anchor="t" lIns="109728" rIns="109728">
+          <a:bodyPr wrap="square" lIns="109728" rIns="109728" anchor="t">
             <a:spAutoFit/>
           </a:bodyPr>
           <a:lstStyle/>
@@ -9314,7 +9001,7 @@
           </a:fontRef>
         </p:style>
         <p:txBody>
-          <a:bodyPr rtlCol="0" anchor="ctr" wrap="square" lIns="18288" rIns="18288"/>
+          <a:bodyPr wrap="square" lIns="18288" rIns="18288" rtlCol="0" anchor="ctr"/>
           <a:lstStyle/>
           <a:p>
             <a:pPr algn="ctr">
@@ -9351,7 +9038,7 @@
           <a:noFill/>
         </p:spPr>
         <p:txBody>
-          <a:bodyPr wrap="square" anchor="ctr" lIns="109728" rIns="109728">
+          <a:bodyPr wrap="square" lIns="109728" rIns="109728" anchor="ctr">
             <a:spAutoFit/>
           </a:bodyPr>
           <a:lstStyle/>
@@ -9390,7 +9077,7 @@
           <a:noFill/>
         </p:spPr>
         <p:txBody>
-          <a:bodyPr wrap="square" anchor="t" lIns="109728" rIns="109728">
+          <a:bodyPr wrap="square" lIns="109728" rIns="109728" anchor="t">
             <a:spAutoFit/>
           </a:bodyPr>
           <a:lstStyle/>
@@ -9451,7 +9138,7 @@
           </a:fontRef>
         </p:style>
         <p:txBody>
-          <a:bodyPr rtlCol="0" anchor="ctr" wrap="square" lIns="18288" rIns="18288"/>
+          <a:bodyPr wrap="square" lIns="18288" rIns="18288" rtlCol="0" anchor="ctr"/>
           <a:lstStyle/>
           <a:p>
             <a:pPr algn="ctr">
@@ -9488,7 +9175,7 @@
           <a:noFill/>
         </p:spPr>
         <p:txBody>
-          <a:bodyPr wrap="square" anchor="ctr" lIns="109728" rIns="109728">
+          <a:bodyPr wrap="square" lIns="109728" rIns="109728" anchor="ctr">
             <a:spAutoFit/>
           </a:bodyPr>
           <a:lstStyle/>
@@ -9527,7 +9214,7 @@
           <a:noFill/>
         </p:spPr>
         <p:txBody>
-          <a:bodyPr wrap="square" anchor="t" lIns="109728" rIns="109728">
+          <a:bodyPr wrap="square" lIns="109728" rIns="109728" anchor="t">
             <a:spAutoFit/>
           </a:bodyPr>
           <a:lstStyle/>
@@ -9588,7 +9275,7 @@
           </a:fontRef>
         </p:style>
         <p:txBody>
-          <a:bodyPr rtlCol="0" anchor="ctr" wrap="square" lIns="137160" rIns="137160"/>
+          <a:bodyPr wrap="square" lIns="137160" rIns="137160" rtlCol="0" anchor="ctr"/>
           <a:lstStyle/>
           <a:p>
             <a:pPr algn="l">
@@ -9641,6 +9328,126 @@
         </p:txBody>
       </p:sp>
     </p:spTree>
+  </p:cSld>
+  <p:clrMapOvr>
+    <a:masterClrMapping/>
+  </p:clrMapOvr>
+</p:sld>
+</file>
+
+<file path=ppt/slides/slide5.xml><?xml version="1.0" encoding="utf-8"?>
+<p:sld xmlns:a="http://schemas.openxmlformats.org/drawingml/2006/main" xmlns:r="http://schemas.openxmlformats.org/officeDocument/2006/relationships" xmlns:p="http://schemas.openxmlformats.org/presentationml/2006/main">
+  <p:cSld>
+    <p:spTree>
+      <p:nvGrpSpPr>
+        <p:cNvPr id="1" name=""/>
+        <p:cNvGrpSpPr/>
+        <p:nvPr/>
+      </p:nvGrpSpPr>
+      <p:grpSpPr>
+        <a:xfrm>
+          <a:off x="0" y="0"/>
+          <a:ext cx="0" cy="0"/>
+          <a:chOff x="0" y="0"/>
+          <a:chExt cx="0" cy="0"/>
+        </a:xfrm>
+      </p:grpSpPr>
+      <p:pic>
+        <p:nvPicPr>
+          <p:cNvPr id="3" name="Picture 2">
+            <a:extLst>
+              <a:ext uri="{FF2B5EF4-FFF2-40B4-BE49-F238E27FC236}">
+                <a16:creationId xmlns:a16="http://schemas.microsoft.com/office/drawing/2014/main" id="{A67FB3CF-F564-6F33-3C59-357353D95DBA}"/>
+              </a:ext>
+            </a:extLst>
+          </p:cNvPr>
+          <p:cNvPicPr>
+            <a:picLocks noChangeAspect="1"/>
+          </p:cNvPicPr>
+          <p:nvPr/>
+        </p:nvPicPr>
+        <p:blipFill>
+          <a:blip r:embed="rId2"/>
+          <a:stretch>
+            <a:fillRect/>
+          </a:stretch>
+        </p:blipFill>
+        <p:spPr>
+          <a:xfrm>
+            <a:off x="0" y="1296044"/>
+            <a:ext cx="12192000" cy="4265911"/>
+          </a:xfrm>
+          <a:prstGeom prst="rect">
+            <a:avLst/>
+          </a:prstGeom>
+        </p:spPr>
+      </p:pic>
+    </p:spTree>
+    <p:extLst>
+      <p:ext uri="{BB962C8B-B14F-4D97-AF65-F5344CB8AC3E}">
+        <p14:creationId xmlns:p14="http://schemas.microsoft.com/office/powerpoint/2010/main" val="2978825678"/>
+      </p:ext>
+    </p:extLst>
+  </p:cSld>
+  <p:clrMapOvr>
+    <a:masterClrMapping/>
+  </p:clrMapOvr>
+</p:sld>
+</file>
+
+<file path=ppt/slides/slide6.xml><?xml version="1.0" encoding="utf-8"?>
+<p:sld xmlns:a="http://schemas.openxmlformats.org/drawingml/2006/main" xmlns:r="http://schemas.openxmlformats.org/officeDocument/2006/relationships" xmlns:p="http://schemas.openxmlformats.org/presentationml/2006/main">
+  <p:cSld>
+    <p:spTree>
+      <p:nvGrpSpPr>
+        <p:cNvPr id="1" name=""/>
+        <p:cNvGrpSpPr/>
+        <p:nvPr/>
+      </p:nvGrpSpPr>
+      <p:grpSpPr>
+        <a:xfrm>
+          <a:off x="0" y="0"/>
+          <a:ext cx="0" cy="0"/>
+          <a:chOff x="0" y="0"/>
+          <a:chExt cx="0" cy="0"/>
+        </a:xfrm>
+      </p:grpSpPr>
+      <p:pic>
+        <p:nvPicPr>
+          <p:cNvPr id="3" name="Picture 2">
+            <a:extLst>
+              <a:ext uri="{FF2B5EF4-FFF2-40B4-BE49-F238E27FC236}">
+                <a16:creationId xmlns:a16="http://schemas.microsoft.com/office/drawing/2014/main" id="{B3FE331B-AFA1-5556-0E91-48E4745CB731}"/>
+              </a:ext>
+            </a:extLst>
+          </p:cNvPr>
+          <p:cNvPicPr>
+            <a:picLocks noChangeAspect="1"/>
+          </p:cNvPicPr>
+          <p:nvPr/>
+        </p:nvPicPr>
+        <p:blipFill>
+          <a:blip r:embed="rId2"/>
+          <a:stretch>
+            <a:fillRect/>
+          </a:stretch>
+        </p:blipFill>
+        <p:spPr>
+          <a:xfrm>
+            <a:off x="0" y="448880"/>
+            <a:ext cx="12192000" cy="5960239"/>
+          </a:xfrm>
+          <a:prstGeom prst="rect">
+            <a:avLst/>
+          </a:prstGeom>
+        </p:spPr>
+      </p:pic>
+    </p:spTree>
+    <p:extLst>
+      <p:ext uri="{BB962C8B-B14F-4D97-AF65-F5344CB8AC3E}">
+        <p14:creationId xmlns:p14="http://schemas.microsoft.com/office/powerpoint/2010/main" val="3558258930"/>
+      </p:ext>
+    </p:extLst>
   </p:cSld>
   <p:clrMapOvr>
     <a:masterClrMapping/>

</xml_diff>